<commit_message>
Explain PP-X contribution composition
Co-authored-by: Cursor <cursoragent@cursor.com>
</commit_message>
<xml_diff>
--- a/ppt/PP-X_Research_Detailed_v2.pptx
+++ b/ppt/PP-X_Research_Detailed_v2.pptx
@@ -31770,8 +31770,8 @@
         </p:nvSpPr>
         <p:spPr>
           <a:xfrm>
-            <a:off x="457200" y="4476750"/>
-            <a:ext cx="11277600" cy="857250"/>
+            <a:off x="457200" y="4362450"/>
+            <a:ext cx="11277600" cy="1143000"/>
           </a:xfrm>
           <a:prstGeom prst="roundRect">
             <a:avLst>
@@ -31815,8 +31815,8 @@
         </p:nvSpPr>
         <p:spPr>
           <a:xfrm>
-            <a:off x="666750" y="4648200"/>
-            <a:ext cx="10858500" cy="495300"/>
+            <a:off x="666750" y="4495800"/>
+            <a:ext cx="10858500" cy="323850"/>
           </a:xfrm>
           <a:prstGeom prst="rect">
             <a:avLst/>
@@ -31831,14 +31831,14 @@
           <a:p>
             <a:pPr algn="ctr"/>
             <a:r>
-              <a:rPr sz="1400" b="1">
+              <a:rPr sz="1300" b="1">
                 <a:solidFill>
                   <a:srgbClr val="FFFFFF"/>
                 </a:solidFill>
                 <a:latin typeface="Arial"/>
                 <a:ea typeface="AppleGothic"/>
               </a:rPr>
-              <a:t>주장 경계  prior+residual, validation, abstention은 각각 기존에 있다. PP-X의 novelty는 typed admissibility + bounded residual authority + physical-unit approval + frozen fallback의 결합이다.</a:t>
+              <a:t>결합 방식  Contract C → 허용 후보 E(C) 제한 → prior-residual 후보 학습 → unit-risk 제약 아래 validation-best executor 선택 → frozen route / fallback</a:t>
             </a:r>
           </a:p>
         </p:txBody>
@@ -31851,8 +31851,8 @@
         </p:nvSpPr>
         <p:spPr>
           <a:xfrm>
-            <a:off x="457200" y="5619750"/>
-            <a:ext cx="11277600" cy="285750"/>
+            <a:off x="666750" y="4933950"/>
+            <a:ext cx="10858500" cy="400050"/>
           </a:xfrm>
           <a:prstGeom prst="rect">
             <a:avLst/>
@@ -31867,6 +31867,42 @@
           <a:p>
             <a:pPr algn="ctr"/>
             <a:r>
+              <a:rPr sz="1300" b="0">
+                <a:solidFill>
+                  <a:srgbClr val="FFFFFF"/>
+                </a:solidFill>
+                <a:latin typeface="Arial"/>
+                <a:ea typeface="AppleGothic"/>
+              </a:rPr>
+              <a:t>차별점  prior+residual·validation·abstention을 나열한 것이 아니라, 앞 단계의 출력이 다음 단계의 허용 입력을 제한하는 하나의 실행 알고리즘으로 만든다.</a:t>
+            </a:r>
+          </a:p>
+        </p:txBody>
+      </p:sp>
+      <p:sp>
+        <p:nvSpPr>
+          <p:cNvPr id="25" name="TextBox 24"/>
+          <p:cNvSpPr txBox="1"/>
+          <p:nvPr/>
+        </p:nvSpPr>
+        <p:spPr>
+          <a:xfrm>
+            <a:off x="457200" y="5734050"/>
+            <a:ext cx="11277600" cy="285750"/>
+          </a:xfrm>
+          <a:prstGeom prst="rect">
+            <a:avLst/>
+          </a:prstGeom>
+          <a:noFill/>
+        </p:spPr>
+        <p:txBody>
+          <a:bodyPr wrap="square">
+            <a:spAutoFit/>
+          </a:bodyPr>
+          <a:lstStyle/>
+          <a:p>
+            <a:pPr algn="ctr"/>
+            <a:r>
               <a:rPr sz="1100" b="0">
                 <a:solidFill>
                   <a:srgbClr val="666666"/>
@@ -31881,7 +31917,7 @@
       </p:sp>
       <p:cxnSp>
         <p:nvCxnSpPr>
-          <p:cNvPr id="25" name="Connector 24"/>
+          <p:cNvPr id="26" name="Connector 25"/>
           <p:cNvCxnSpPr/>
           <p:nvPr/>
         </p:nvCxnSpPr>
@@ -31916,7 +31952,7 @@
       </p:cxnSp>
       <p:sp>
         <p:nvSpPr>
-          <p:cNvPr id="26" name="TextBox 25"/>
+          <p:cNvPr id="27" name="TextBox 26"/>
           <p:cNvSpPr txBox="1"/>
           <p:nvPr/>
         </p:nvSpPr>
@@ -31952,7 +31988,7 @@
       </p:sp>
       <p:sp>
         <p:nvSpPr>
-          <p:cNvPr id="27" name="TextBox 26"/>
+          <p:cNvPr id="28" name="TextBox 27"/>
           <p:cNvSpPr txBox="1"/>
           <p:nvPr/>
         </p:nvSpPr>

</xml_diff>

<commit_message>
Ground PP-X impact claims in current evidence
Co-authored-by: Cursor <cursoragent@cursor.com>
</commit_message>
<xml_diff>
--- a/ppt/PP-X_Research_Detailed_v2.pptx
+++ b/ppt/PP-X_Research_Detailed_v2.pptx
@@ -33535,7 +33535,7 @@
                 <a:latin typeface="Arial"/>
                 <a:ea typeface="AppleGothic"/>
               </a:rPr>
-              <a:t>그래서 PP-X로 무엇을 할 수 있는가</a:t>
+              <a:t>그래서 외삽에서 무엇이 좋아졌는가</a:t>
             </a:r>
           </a:p>
         </p:txBody>
@@ -33571,7 +33571,7 @@
                 <a:latin typeface="Arial"/>
                 <a:ea typeface="AppleGothic"/>
               </a:rPr>
-              <a:t>외삽 가정을 논문 속 아이디어가 아니라, 새로운 cohort에 적용할 수 있는 승인·거절 결정으로 바꾼다.</a:t>
+              <a:t>현재 retrospective 데이터 안에서 확인된 효과와 아직 주장할 수 없는 범위를 분리한다.</a:t>
             </a:r>
           </a:p>
         </p:txBody>
@@ -33607,7 +33607,7 @@
                 <a:latin typeface="Arial"/>
                 <a:ea typeface="AppleGothic"/>
               </a:rPr>
-              <a:t>현장 문제  학습 범위를 벗어난 배터리·설비·재료에서는 ‘어떤 prior를 믿고 얼마나 수정할지’를 test 정답 없이 결정해야 한다.</a:t>
+              <a:t>비교 대상  하나의 prior나 optional module을 모든 데이터에 항상 켜는 외삽 모델</a:t>
             </a:r>
           </a:p>
         </p:txBody>
@@ -33690,7 +33690,7 @@
                 <a:latin typeface="Arial"/>
                 <a:ea typeface="AppleGothic"/>
               </a:rPr>
-              <a:t>새 cohort 수명 예측</a:t>
+              <a:t>① 평균 예측오차</a:t>
             </a:r>
           </a:p>
         </p:txBody>
@@ -33726,7 +33726,7 @@
                 <a:latin typeface="Arial"/>
                 <a:ea typeface="AppleGothic"/>
               </a:rPr>
-              <a:t>새 충전조건·운전조건·재료에서</a:t>
+              <a:t>각 contract에서 validation이 지지한</a:t>
             </a:r>
           </a:p>
           <a:p>
@@ -33739,7 +33739,7 @@
                 <a:latin typeface="Arial"/>
                 <a:ea typeface="AppleGothic"/>
               </a:rPr>
-              <a:t>경계·추세·열화 prior가 유효한지</a:t>
+              <a:t>executor만 선택해, 맞는 구조의</a:t>
             </a:r>
           </a:p>
           <a:p>
@@ -33752,7 +33752,7 @@
                 <a:latin typeface="Arial"/>
                 <a:ea typeface="AppleGothic"/>
               </a:rPr>
-              <a:t>source/validation evidence로 먼저 판정</a:t>
+              <a:t>외삽 이득은 유지</a:t>
             </a:r>
           </a:p>
         </p:txBody>
@@ -33823,7 +33823,7 @@
                 <a:latin typeface="Arial"/>
                 <a:ea typeface="AppleGothic"/>
               </a:rPr>
-              <a:t>무조건 적용한 prior가</a:t>
+              <a:t>개발 결과</a:t>
             </a:r>
           </a:p>
           <a:p>
@@ -33836,7 +33836,20 @@
                 <a:latin typeface="Arial"/>
                 <a:ea typeface="AppleGothic"/>
               </a:rPr>
-              <a:t>말기 RUL을 망치는 위험 감소</a:t>
+              <a:t>동일예산 최강 비교군 대비 8/9 우세</a:t>
+            </a:r>
+          </a:p>
+          <a:p>
+            <a:pPr algn="ctr"/>
+            <a:r>
+              <a:rPr sz="1200" b="1">
+                <a:solidFill>
+                  <a:srgbClr val="0072B2"/>
+                </a:solidFill>
+                <a:latin typeface="Arial"/>
+                <a:ea typeface="AppleGothic"/>
+              </a:rPr>
+              <a:t>paired GM-RMSE 33.8% 감소</a:t>
             </a:r>
           </a:p>
         </p:txBody>
@@ -33919,7 +33932,7 @@
                 <a:latin typeface="Arial"/>
                 <a:ea typeface="AppleGothic"/>
               </a:rPr>
-              <a:t>도메인별 지식 재사용</a:t>
+              <a:t>② 전역 적용 붕괴 방지</a:t>
             </a:r>
           </a:p>
         </p:txBody>
@@ -33955,7 +33968,7 @@
                 <a:latin typeface="Arial"/>
                 <a:ea typeface="AppleGothic"/>
               </a:rPr>
-              <a:t>배터리는 failure boundary,</a:t>
+              <a:t>모든 셋에 같은 bound·scale을</a:t>
             </a:r>
           </a:p>
           <a:p>
@@ -33968,7 +33981,7 @@
                 <a:latin typeface="Arial"/>
                 <a:ea typeface="AppleGothic"/>
               </a:rPr>
-              <a:t>균열은 진행 법칙, 엔진은 regime처럼</a:t>
+              <a:t>항상 켜지 않고, 해당 contract에서</a:t>
             </a:r>
           </a:p>
           <a:p>
@@ -33981,7 +33994,7 @@
                 <a:latin typeface="Arial"/>
                 <a:ea typeface="AppleGothic"/>
               </a:rPr>
-              <a:t>서로 다른 지식을 같은 절차로 연결</a:t>
+              <a:t>지지된 executor만 최종 route에 포함</a:t>
             </a:r>
           </a:p>
         </p:txBody>
@@ -34052,7 +34065,7 @@
                 <a:latin typeface="Arial"/>
                 <a:ea typeface="AppleGothic"/>
               </a:rPr>
-              <a:t>새 도메인마다 완전히 다른</a:t>
+              <a:t>직접 반례</a:t>
             </a:r>
           </a:p>
           <a:p>
@@ -34065,7 +34078,20 @@
                 <a:latin typeface="Arial"/>
                 <a:ea typeface="AppleGothic"/>
               </a:rPr>
-              <a:t>배포 논리를 다시 만들 필요 감소</a:t>
+              <a:t>MICH fixed bound ΔR² −.291</a:t>
+            </a:r>
+          </a:p>
+          <a:p>
+            <a:pPr algn="ctr"/>
+            <a:r>
+              <a:rPr sz="1200" b="1">
+                <a:solidFill>
+                  <a:srgbClr val="222222"/>
+                </a:solidFill>
+                <a:latin typeface="Arial"/>
+                <a:ea typeface="AppleGothic"/>
+              </a:rPr>
+              <a:t>RWTH dual-scale ΔR² −.037</a:t>
             </a:r>
           </a:p>
         </p:txBody>
@@ -34148,7 +34174,7 @@
                 <a:latin typeface="Arial"/>
                 <a:ea typeface="AppleGothic"/>
               </a:rPr>
-              <a:t>안전한 자동 후퇴</a:t>
+              <a:t>③ 유닛 단위 안정성</a:t>
             </a:r>
           </a:p>
         </p:txBody>
@@ -34184,7 +34210,7 @@
                 <a:latin typeface="Arial"/>
                 <a:ea typeface="AppleGothic"/>
               </a:rPr>
-              <a:t>prior나 executor의 이득 근거가 없으면</a:t>
+              <a:t>평균 RMSE만 보지 않고 unit wins와</a:t>
             </a:r>
           </a:p>
           <a:p>
@@ -34197,7 +34223,7 @@
                 <a:latin typeface="Arial"/>
                 <a:ea typeface="AppleGothic"/>
               </a:rPr>
-              <a:t>미리 정한 direct·persistence 경로</a:t>
+              <a:t>worst-unit ratio를 승인 조건에 포함해</a:t>
             </a:r>
           </a:p>
           <a:p>
@@ -34210,7 +34236,7 @@
                 <a:latin typeface="Arial"/>
                 <a:ea typeface="AppleGothic"/>
               </a:rPr>
-              <a:t>또는 abstention으로 전환</a:t>
+              <a:t>일부 설비에 손해가 몰리는 route 제한</a:t>
             </a:r>
           </a:p>
         </p:txBody>
@@ -34281,7 +34307,7 @@
                 <a:latin typeface="Arial"/>
                 <a:ea typeface="AppleGothic"/>
               </a:rPr>
-              <a:t>틀린 구조를 억지로 실행하지 않고</a:t>
+              <a:t>직접 근거</a:t>
             </a:r>
           </a:p>
           <a:p>
@@ -34294,7 +34320,20 @@
                 <a:latin typeface="Arial"/>
                 <a:ea typeface="AppleGothic"/>
               </a:rPr>
-              <a:t>최소한의 예측 경로를 유지</a:t>
+              <a:t>HUST transport 15/16 unit 개선</a:t>
+            </a:r>
+          </a:p>
+          <a:p>
+            <a:pPr algn="ctr"/>
+            <a:r>
+              <a:rPr sz="1200" b="1">
+                <a:solidFill>
+                  <a:srgbClr val="E69F00"/>
+                </a:solidFill>
+                <a:latin typeface="Arial"/>
+                <a:ea typeface="AppleGothic"/>
+              </a:rPr>
+              <a:t>MICH dual-scale 7/8 unit 개선</a:t>
             </a:r>
           </a:p>
         </p:txBody>
@@ -34377,7 +34416,7 @@
                 <a:latin typeface="Arial"/>
                 <a:ea typeface="AppleGothic"/>
               </a:rPr>
-              <a:t>감사 가능한 의사결정</a:t>
+              <a:t>④ 잘못된 승인 감소</a:t>
             </a:r>
           </a:p>
         </p:txBody>
@@ -34413,7 +34452,7 @@
                 <a:latin typeface="Arial"/>
                 <a:ea typeface="AppleGothic"/>
               </a:rPr>
-              <a:t>왜 이 prior·bound·history·transport가</a:t>
+              <a:t>12-domain common-backbone audit에서</a:t>
             </a:r>
           </a:p>
           <a:p>
@@ -34426,7 +34465,7 @@
                 <a:latin typeface="Arial"/>
                 <a:ea typeface="AppleGothic"/>
               </a:rPr>
-              <a:t>켜졌는지 unit-level evidence와</a:t>
+              <a:t>unit-gain CI 조건을 추가해</a:t>
             </a:r>
           </a:p>
           <a:p>
@@ -34439,7 +34478,7 @@
                 <a:latin typeface="Arial"/>
                 <a:ea typeface="AppleGothic"/>
               </a:rPr>
-              <a:t>frozen artifact로 추적</a:t>
+              <a:t>근거가 약한 prior 승인을 걸러냄</a:t>
             </a:r>
           </a:p>
         </p:txBody>
@@ -34510,7 +34549,7 @@
                 <a:latin typeface="Arial"/>
                 <a:ea typeface="AppleGothic"/>
               </a:rPr>
-              <a:t>의료·제조·예지보전에서</a:t>
+              <a:t>retrospective policy audit</a:t>
             </a:r>
           </a:p>
           <a:p>
@@ -34523,7 +34562,20 @@
                 <a:latin typeface="Arial"/>
                 <a:ea typeface="AppleGothic"/>
               </a:rPr>
-              <a:t>사후 튜닝과 선택 편향을 점검</a:t>
+              <a:t>false accept 2 → 0</a:t>
+            </a:r>
+          </a:p>
+          <a:p>
+            <a:pPr algn="ctr"/>
+            <a:r>
+              <a:rPr sz="1200" b="1">
+                <a:solidFill>
+                  <a:srgbClr val="222222"/>
+                </a:solidFill>
+                <a:latin typeface="Arial"/>
+                <a:ea typeface="AppleGothic"/>
+              </a:rPr>
+              <a:t>선택 정확도 .667 → .833</a:t>
             </a:r>
           </a:p>
         </p:txBody>
@@ -34581,8 +34633,8 @@
         </p:nvSpPr>
         <p:spPr>
           <a:xfrm>
-            <a:off x="666750" y="5124450"/>
-            <a:ext cx="10858500" cy="438150"/>
+            <a:off x="666750" y="5067300"/>
+            <a:ext cx="10858500" cy="533400"/>
           </a:xfrm>
           <a:prstGeom prst="rect">
             <a:avLst/>
@@ -34604,14 +34656,50 @@
                 <a:latin typeface="Arial"/>
                 <a:ea typeface="AppleGothic"/>
               </a:rPr>
-              <a:t>최종 가치  PP-X는 ‘항상 맞는 보편 모델’이 아니라, 외삽에 필요한 가정을 조건부로 사용하고 근거가 없으면 적용하지 않게 만드는 risk-aware prediction workflow다.</a:t>
+              <a:t>기여 효과  현재 평가 데이터셋에서 PP-X는 validation이 지지한 구조만 실행해 전역 prior/executor의 성능 붕괴를 줄이고, 평균 오차와 unit-level risk를 함께 관리했다.</a:t>
+            </a:r>
+          </a:p>
+        </p:txBody>
+      </p:sp>
+      <p:sp>
+        <p:nvSpPr>
+          <p:cNvPr id="29" name="TextBox 28"/>
+          <p:cNvSpPr txBox="1"/>
+          <p:nvPr/>
+        </p:nvSpPr>
+        <p:spPr>
+          <a:xfrm>
+            <a:off x="457200" y="5829300"/>
+            <a:ext cx="11277600" cy="209550"/>
+          </a:xfrm>
+          <a:prstGeom prst="rect">
+            <a:avLst/>
+          </a:prstGeom>
+          <a:noFill/>
+        </p:spPr>
+        <p:txBody>
+          <a:bodyPr wrap="square">
+            <a:spAutoFit/>
+          </a:bodyPr>
+          <a:lstStyle/>
+          <a:p>
+            <a:pPr algn="ctr"/>
+            <a:r>
+              <a:rPr sz="1000" b="1">
+                <a:solidFill>
+                  <a:srgbClr val="9B1C1C"/>
+                </a:solidFill>
+                <a:latin typeface="Arial"/>
+                <a:ea typeface="AppleGothic"/>
+              </a:rPr>
+              <a:t>범위  위 수치는 retrospective evidence다. 보지 않은 미래 cohort에서 같은 실패 감소를 보장한다는 주장은 하지 않는다.</a:t>
             </a:r>
           </a:p>
         </p:txBody>
       </p:sp>
       <p:cxnSp>
         <p:nvCxnSpPr>
-          <p:cNvPr id="29" name="Connector 28"/>
+          <p:cNvPr id="30" name="Connector 29"/>
           <p:cNvCxnSpPr/>
           <p:nvPr/>
         </p:nvCxnSpPr>
@@ -34646,7 +34734,7 @@
       </p:cxnSp>
       <p:sp>
         <p:nvSpPr>
-          <p:cNvPr id="30" name="TextBox 29"/>
+          <p:cNvPr id="31" name="TextBox 30"/>
           <p:cNvSpPr txBox="1"/>
           <p:nvPr/>
         </p:nvSpPr>
@@ -34682,7 +34770,7 @@
       </p:sp>
       <p:sp>
         <p:nvSpPr>
-          <p:cNvPr id="31" name="TextBox 30"/>
+          <p:cNvPr id="32" name="TextBox 31"/>
           <p:cNvSpPr txBox="1"/>
           <p:nvPr/>
         </p:nvSpPr>

</xml_diff>

<commit_message>
Add exact cross-domain stability comparisons
Co-authored-by: Cursor <cursoragent@cursor.com>
</commit_message>
<xml_diff>
--- a/ppt/PP-X_Research_Detailed_v2.pptx
+++ b/ppt/PP-X_Research_Detailed_v2.pptx
@@ -37994,7 +37994,7 @@
                 <a:latin typeface="Arial"/>
                 <a:ea typeface="AppleGothic"/>
               </a:rPr>
-              <a:t>통계와 주장 경계</a:t>
+              <a:t>소표본 비모수 검정</a:t>
             </a:r>
           </a:p>
         </p:txBody>
@@ -38030,7 +38030,7 @@
                 <a:latin typeface="Arial"/>
                 <a:ea typeface="AppleGothic"/>
               </a:rPr>
-              <a:t>최강 동일예산 대비 8/9 우세</a:t>
+              <a:t>Engression 대비 MAD  .061 vs .280</a:t>
             </a:r>
           </a:p>
           <a:p>
@@ -38043,7 +38043,7 @@
                 <a:latin typeface="Arial"/>
                 <a:ea typeface="AppleGothic"/>
               </a:rPr>
-              <a:t>exact sign p=.0391</a:t>
+              <a:t>paired exact p=.0391</a:t>
             </a:r>
           </a:p>
           <a:p>
@@ -38056,7 +38056,7 @@
                 <a:latin typeface="Arial"/>
                 <a:ea typeface="AppleGothic"/>
               </a:rPr>
-              <a:t>분산검정은 Holm 보정 후 q&gt;.05</a:t>
+              <a:t>GroupDRO .0156 · MLP .0469</a:t>
             </a:r>
           </a:p>
           <a:p>
@@ -38069,7 +38069,7 @@
                 <a:latin typeface="Arial"/>
                 <a:ea typeface="AppleGothic"/>
               </a:rPr>
-              <a:t>→ 도메인 분산은 secondary evidence</a:t>
+              <a:t>V-REx .0469</a:t>
             </a:r>
           </a:p>
         </p:txBody>
@@ -38186,7 +38186,7 @@
                 <a:latin typeface="Arial"/>
                 <a:ea typeface="AppleGothic"/>
               </a:rPr>
-              <a:t>주의  R²는 데이터셋별 target 분산에 민감하므로 unit log-RMSE·worst-unit regret과 함께 해석한다.</a:t>
+              <a:t>8개 모델 동시 Holm 보정은 비유의. 전체표는 성공률·최악값·unit log-RMSE와 함께 해석한다.</a:t>
             </a:r>
           </a:p>
         </p:txBody>

</xml_diff>

<commit_message>
Compare PP-X with selective regression
Co-authored-by: Cursor <cursoragent@cursor.com>
</commit_message>
<xml_diff>
--- a/ppt/PP-X_Research_Detailed_v2.pptx
+++ b/ppt/PP-X_Research_Detailed_v2.pptx
@@ -8,11 +8,9 @@
     <p:sldId id="256" r:id="rId7"/>
     <p:sldId id="257" r:id="rId8"/>
     <p:sldId id="258" r:id="rId9"/>
+    <p:sldId id="263" r:id="rId14"/>
     <p:sldId id="259" r:id="rId10"/>
     <p:sldId id="260" r:id="rId11"/>
-    <p:sldId id="261" r:id="rId12"/>
-    <p:sldId id="262" r:id="rId13"/>
-    <p:sldId id="263" r:id="rId14"/>
     <p:sldId id="264" r:id="rId15"/>
     <p:sldId id="265" r:id="rId16"/>
     <p:sldId id="266" r:id="rId17"/>
@@ -29,7 +27,10 @@
     <p:sldId id="277" r:id="rId28"/>
     <p:sldId id="278" r:id="rId29"/>
     <p:sldId id="279" r:id="rId30"/>
+    <p:sldId id="261" r:id="rId12"/>
+    <p:sldId id="295" r:id="rId46"/>
     <p:sldId id="280" r:id="rId31"/>
+    <p:sldId id="262" r:id="rId13"/>
     <p:sldId id="281" r:id="rId32"/>
     <p:sldId id="282" r:id="rId33"/>
     <p:sldId id="283" r:id="rId34"/>
@@ -3260,14 +3261,14 @@
           <a:p>
             <a:pPr algn="ctr"/>
             <a:r>
-              <a:rPr sz="2800" b="1">
+              <a:rPr sz="3000" b="1">
                 <a:solidFill>
                   <a:srgbClr val="222222"/>
                 </a:solidFill>
                 <a:latin typeface="Arial"/>
                 <a:ea typeface="AppleGothic"/>
               </a:rPr>
-              <a:t>Prior-Adaptive Extrapolation</a:t>
+              <a:t>PP-X</a:t>
             </a:r>
           </a:p>
         </p:txBody>
@@ -3303,7 +3304,7 @@
                 <a:latin typeface="Arial"/>
                 <a:ea typeface="AppleGothic"/>
               </a:rPr>
-              <a:t>for Robust Prediction Beyond Observed Support</a:t>
+              <a:t>Validation-Approved Prior-Residual Extrapolation</a:t>
             </a:r>
           </a:p>
         </p:txBody>
@@ -3375,7 +3376,7 @@
                 <a:latin typeface="Arial"/>
                 <a:ea typeface="AppleGothic"/>
               </a:rPr>
-              <a:t>논문 메인 모델  ·  PP-X</a:t>
+              <a:t>전체 연구 지도  ·  Prior-Adaptive Extrapolation</a:t>
             </a:r>
           </a:p>
         </p:txBody>
@@ -4535,7 +4536,7 @@
                 <a:latin typeface="Arial"/>
                 <a:ea typeface="AppleGothic"/>
               </a:rPr>
-              <a:t>10/39</a:t>
+              <a:t>8/40</a:t>
             </a:r>
           </a:p>
         </p:txBody>
@@ -5353,7 +5354,7 @@
                 <a:latin typeface="Arial"/>
                 <a:ea typeface="AppleGothic"/>
               </a:rPr>
-              <a:t>11/39</a:t>
+              <a:t>9/40</a:t>
             </a:r>
           </a:p>
         </p:txBody>
@@ -6730,7 +6731,7 @@
                 <a:latin typeface="Arial"/>
                 <a:ea typeface="AppleGothic"/>
               </a:rPr>
-              <a:t>12/39</a:t>
+              <a:t>10/40</a:t>
             </a:r>
           </a:p>
         </p:txBody>
@@ -7862,7 +7863,7 @@
                 <a:latin typeface="Arial"/>
                 <a:ea typeface="AppleGothic"/>
               </a:rPr>
-              <a:t>13/39</a:t>
+              <a:t>11/40</a:t>
             </a:r>
           </a:p>
         </p:txBody>
@@ -9500,7 +9501,7 @@
                 <a:latin typeface="Arial"/>
                 <a:ea typeface="AppleGothic"/>
               </a:rPr>
-              <a:t>14/39</a:t>
+              <a:t>12/40</a:t>
             </a:r>
           </a:p>
         </p:txBody>
@@ -9879,7 +9880,7 @@
                 <a:latin typeface="Arial"/>
                 <a:ea typeface="AppleGothic"/>
               </a:rPr>
-              <a:t>15/39</a:t>
+              <a:t>13/40</a:t>
             </a:r>
           </a:p>
         </p:txBody>
@@ -10915,7 +10916,7 @@
                 <a:latin typeface="Arial"/>
                 <a:ea typeface="AppleGothic"/>
               </a:rPr>
-              <a:t>16/39</a:t>
+              <a:t>14/40</a:t>
             </a:r>
           </a:p>
         </p:txBody>
@@ -11295,7 +11296,7 @@
                 <a:latin typeface="Arial"/>
                 <a:ea typeface="AppleGothic"/>
               </a:rPr>
-              <a:t>17/39</a:t>
+              <a:t>15/40</a:t>
             </a:r>
           </a:p>
         </p:txBody>
@@ -11675,7 +11676,7 @@
                 <a:latin typeface="Arial"/>
                 <a:ea typeface="AppleGothic"/>
               </a:rPr>
-              <a:t>18/39</a:t>
+              <a:t>16/40</a:t>
             </a:r>
           </a:p>
         </p:txBody>
@@ -12939,7 +12940,7 @@
                 <a:latin typeface="Arial"/>
                 <a:ea typeface="AppleGothic"/>
               </a:rPr>
-              <a:t>19/39</a:t>
+              <a:t>17/40</a:t>
             </a:r>
           </a:p>
         </p:txBody>
@@ -13639,7 +13640,7 @@
                 <a:latin typeface="Arial"/>
                 <a:ea typeface="AppleGothic"/>
               </a:rPr>
-              <a:t>2/39</a:t>
+              <a:t>2/40</a:t>
             </a:r>
           </a:p>
         </p:txBody>
@@ -13982,7 +13983,7 @@
                 <a:latin typeface="Arial"/>
                 <a:ea typeface="AppleGothic"/>
               </a:rPr>
-              <a:t>20/39</a:t>
+              <a:t>18/40</a:t>
             </a:r>
           </a:p>
         </p:txBody>
@@ -15622,7 +15623,7 @@
                 <a:latin typeface="Arial"/>
                 <a:ea typeface="AppleGothic"/>
               </a:rPr>
-              <a:t>21/39</a:t>
+              <a:t>19/40</a:t>
             </a:r>
           </a:p>
         </p:txBody>
@@ -16037,7 +16038,7 @@
                 <a:latin typeface="Arial"/>
                 <a:ea typeface="AppleGothic"/>
               </a:rPr>
-              <a:t>22/39</a:t>
+              <a:t>20/40</a:t>
             </a:r>
           </a:p>
         </p:txBody>
@@ -16900,7 +16901,7 @@
                 <a:latin typeface="Arial"/>
                 <a:ea typeface="AppleGothic"/>
               </a:rPr>
-              <a:t>23/39</a:t>
+              <a:t>21/40</a:t>
             </a:r>
           </a:p>
         </p:txBody>
@@ -18528,7 +18529,7 @@
                 <a:latin typeface="Arial"/>
                 <a:ea typeface="AppleGothic"/>
               </a:rPr>
-              <a:t>24/39</a:t>
+              <a:t>22/40</a:t>
             </a:r>
           </a:p>
         </p:txBody>
@@ -19831,7 +19832,7 @@
                 <a:latin typeface="Arial"/>
                 <a:ea typeface="AppleGothic"/>
               </a:rPr>
-              <a:t>25/39</a:t>
+              <a:t>25/40</a:t>
             </a:r>
           </a:p>
         </p:txBody>
@@ -21184,7 +21185,7 @@
                 <a:latin typeface="Arial"/>
                 <a:ea typeface="AppleGothic"/>
               </a:rPr>
-              <a:t>26/39</a:t>
+              <a:t>27/40</a:t>
             </a:r>
           </a:p>
         </p:txBody>
@@ -21936,7 +21937,7 @@
                 <a:latin typeface="Arial"/>
                 <a:ea typeface="AppleGothic"/>
               </a:rPr>
-              <a:t>27/39</a:t>
+              <a:t>28/40</a:t>
             </a:r>
           </a:p>
         </p:txBody>
@@ -22814,7 +22815,7 @@
                 <a:latin typeface="Arial"/>
                 <a:ea typeface="AppleGothic"/>
               </a:rPr>
-              <a:t>28/39</a:t>
+              <a:t>29/40</a:t>
             </a:r>
           </a:p>
         </p:txBody>
@@ -23646,7 +23647,7 @@
                 <a:latin typeface="Arial"/>
                 <a:ea typeface="AppleGothic"/>
               </a:rPr>
-              <a:t>29/39</a:t>
+              <a:t>30/40</a:t>
             </a:r>
           </a:p>
         </p:txBody>
@@ -25139,7 +25140,7 @@
                 <a:latin typeface="Arial"/>
                 <a:ea typeface="AppleGothic"/>
               </a:rPr>
-              <a:t>3/39</a:t>
+              <a:t>3/40</a:t>
             </a:r>
           </a:p>
         </p:txBody>
@@ -25495,7 +25496,7 @@
                 <a:latin typeface="Arial"/>
                 <a:ea typeface="AppleGothic"/>
               </a:rPr>
-              <a:t>30/39</a:t>
+              <a:t>31/40</a:t>
             </a:r>
           </a:p>
         </p:txBody>
@@ -25851,7 +25852,7 @@
                 <a:latin typeface="Arial"/>
                 <a:ea typeface="AppleGothic"/>
               </a:rPr>
-              <a:t>31/39</a:t>
+              <a:t>32/40</a:t>
             </a:r>
           </a:p>
         </p:txBody>
@@ -26207,7 +26208,7 @@
                 <a:latin typeface="Arial"/>
                 <a:ea typeface="AppleGothic"/>
               </a:rPr>
-              <a:t>32/39</a:t>
+              <a:t>33/40</a:t>
             </a:r>
           </a:p>
         </p:txBody>
@@ -27039,7 +27040,7 @@
                 <a:latin typeface="Arial"/>
                 <a:ea typeface="AppleGothic"/>
               </a:rPr>
-              <a:t>33/39</a:t>
+              <a:t>34/40</a:t>
             </a:r>
           </a:p>
         </p:txBody>
@@ -28352,7 +28353,7 @@
                 <a:latin typeface="Arial"/>
                 <a:ea typeface="AppleGothic"/>
               </a:rPr>
-              <a:t>34/39</a:t>
+              <a:t>35/40</a:t>
             </a:r>
           </a:p>
         </p:txBody>
@@ -30464,7 +30465,7 @@
                 <a:latin typeface="Arial"/>
                 <a:ea typeface="AppleGothic"/>
               </a:rPr>
-              <a:t>35/39</a:t>
+              <a:t>36/40</a:t>
             </a:r>
           </a:p>
         </p:txBody>
@@ -31562,7 +31563,7 @@
                 <a:latin typeface="Arial"/>
                 <a:ea typeface="AppleGothic"/>
               </a:rPr>
-              <a:t>36/39</a:t>
+              <a:t>37/40</a:t>
             </a:r>
           </a:p>
         </p:txBody>
@@ -32945,7 +32946,7 @@
                 <a:latin typeface="Arial"/>
                 <a:ea typeface="AppleGothic"/>
               </a:rPr>
-              <a:t>38/39</a:t>
+              <a:t>39/40</a:t>
             </a:r>
           </a:p>
         </p:txBody>
@@ -34147,7 +34148,7 @@
                 <a:latin typeface="Arial"/>
                 <a:ea typeface="AppleGothic"/>
               </a:rPr>
-              <a:t>39/39</a:t>
+              <a:t>40/40</a:t>
             </a:r>
           </a:p>
         </p:txBody>
@@ -35303,7 +35304,1359 @@
                 <a:latin typeface="Arial"/>
                 <a:ea typeface="AppleGothic"/>
               </a:rPr>
-              <a:t>4/39</a:t>
+              <a:t>5/40</a:t>
+            </a:r>
+          </a:p>
+        </p:txBody>
+      </p:sp>
+    </p:spTree>
+  </p:cSld>
+  <p:clrMapOvr>
+    <a:masterClrMapping/>
+  </p:clrMapOvr>
+</p:sld>
+</file>
+
+<file path=ppt/slides/slide40.xml><?xml version="1.0" encoding="utf-8"?>
+<p:sld xmlns:a="http://schemas.openxmlformats.org/drawingml/2006/main" xmlns:p="http://schemas.openxmlformats.org/presentationml/2006/main" xmlns:r="http://schemas.openxmlformats.org/officeDocument/2006/relationships">
+  <p:cSld>
+    <p:spTree>
+      <p:nvGrpSpPr>
+        <p:cNvPr id="1" name=""/>
+        <p:cNvGrpSpPr/>
+        <p:nvPr/>
+      </p:nvGrpSpPr>
+      <p:grpSpPr/>
+      <p:sp>
+        <p:nvSpPr>
+          <p:cNvPr id="2" name="Rectangle 1"/>
+          <p:cNvSpPr/>
+          <p:nvPr/>
+        </p:nvSpPr>
+        <p:spPr>
+          <a:xfrm>
+            <a:off x="0" y="0"/>
+            <a:ext cx="12192000" cy="6858000"/>
+          </a:xfrm>
+          <a:prstGeom prst="rect">
+            <a:avLst/>
+          </a:prstGeom>
+          <a:solidFill>
+            <a:srgbClr val="FFFFFF"/>
+          </a:solidFill>
+          <a:ln>
+            <a:noFill/>
+          </a:ln>
+        </p:spPr>
+        <p:style>
+          <a:lnRef idx="1">
+            <a:schemeClr val="accent1"/>
+          </a:lnRef>
+          <a:fillRef idx="3">
+            <a:schemeClr val="accent1"/>
+          </a:fillRef>
+          <a:effectRef idx="2">
+            <a:schemeClr val="accent1"/>
+          </a:effectRef>
+          <a:fontRef idx="minor">
+            <a:schemeClr val="lt1"/>
+          </a:fontRef>
+        </p:style>
+        <p:txBody>
+          <a:bodyPr rtlCol="0" anchor="ctr"/>
+          <a:lstStyle/>
+          <a:p>
+            <a:pPr algn="ctr"/>
+          </a:p>
+        </p:txBody>
+      </p:sp>
+      <p:sp>
+        <p:nvSpPr>
+          <p:cNvPr id="3" name="Rectangle 2"/>
+          <p:cNvSpPr/>
+          <p:nvPr/>
+        </p:nvSpPr>
+        <p:spPr>
+          <a:xfrm>
+            <a:off x="0" y="0"/>
+            <a:ext cx="12192000" cy="28575"/>
+          </a:xfrm>
+          <a:prstGeom prst="rect">
+            <a:avLst/>
+          </a:prstGeom>
+          <a:solidFill>
+            <a:srgbClr val="0072B2"/>
+          </a:solidFill>
+          <a:ln>
+            <a:noFill/>
+          </a:ln>
+        </p:spPr>
+        <p:style>
+          <a:lnRef idx="1">
+            <a:schemeClr val="accent1"/>
+          </a:lnRef>
+          <a:fillRef idx="3">
+            <a:schemeClr val="accent1"/>
+          </a:fillRef>
+          <a:effectRef idx="2">
+            <a:schemeClr val="accent1"/>
+          </a:effectRef>
+          <a:fontRef idx="minor">
+            <a:schemeClr val="lt1"/>
+          </a:fontRef>
+        </p:style>
+        <p:txBody>
+          <a:bodyPr rtlCol="0" anchor="ctr"/>
+          <a:lstStyle/>
+          <a:p>
+            <a:pPr algn="ctr"/>
+          </a:p>
+        </p:txBody>
+      </p:sp>
+      <p:sp>
+        <p:nvSpPr>
+          <p:cNvPr id="4" name="TextBox 3"/>
+          <p:cNvSpPr txBox="1"/>
+          <p:nvPr/>
+        </p:nvSpPr>
+        <p:spPr>
+          <a:xfrm>
+            <a:off x="457200" y="209550"/>
+            <a:ext cx="11239500" cy="304800"/>
+          </a:xfrm>
+          <a:prstGeom prst="rect">
+            <a:avLst/>
+          </a:prstGeom>
+          <a:noFill/>
+        </p:spPr>
+        <p:txBody>
+          <a:bodyPr wrap="square">
+            <a:spAutoFit/>
+          </a:bodyPr>
+          <a:lstStyle/>
+          <a:p>
+            <a:pPr algn="l"/>
+            <a:r>
+              <a:rPr sz="2200" b="1">
+                <a:solidFill>
+                  <a:srgbClr val="222222"/>
+                </a:solidFill>
+                <a:latin typeface="Arial"/>
+                <a:ea typeface="AppleGothic"/>
+              </a:rPr>
+              <a:t>동일 coverage — 검정 기반 Selective Regression</a:t>
+            </a:r>
+          </a:p>
+        </p:txBody>
+      </p:sp>
+      <p:sp>
+        <p:nvSpPr>
+          <p:cNvPr id="5" name="TextBox 4"/>
+          <p:cNvSpPr txBox="1"/>
+          <p:nvPr/>
+        </p:nvSpPr>
+        <p:spPr>
+          <a:xfrm>
+            <a:off x="457200" y="514350"/>
+            <a:ext cx="11239500" cy="190500"/>
+          </a:xfrm>
+          <a:prstGeom prst="rect">
+            <a:avLst/>
+          </a:prstGeom>
+          <a:noFill/>
+        </p:spPr>
+        <p:txBody>
+          <a:bodyPr wrap="square">
+            <a:spAutoFit/>
+          </a:bodyPr>
+          <a:lstStyle/>
+          <a:p>
+            <a:pPr algn="l"/>
+            <a:r>
+              <a:rPr sz="1200" b="0">
+                <a:solidFill>
+                  <a:srgbClr val="666666"/>
+                </a:solidFill>
+                <a:latin typeface="Arial"/>
+                <a:ea typeface="AppleGothic"/>
+              </a:rPr>
+              <a:t>Noskov–Fishkov–Panov Algorithm 1 재현  ·  Gaussian NW + variance/density acceptance test</a:t>
+            </a:r>
+          </a:p>
+        </p:txBody>
+      </p:sp>
+      <p:sp>
+        <p:nvSpPr>
+          <p:cNvPr id="6" name="TextBox 5"/>
+          <p:cNvSpPr txBox="1"/>
+          <p:nvPr/>
+        </p:nvSpPr>
+        <p:spPr>
+          <a:xfrm>
+            <a:off x="457200" y="819150"/>
+            <a:ext cx="11277600" cy="285750"/>
+          </a:xfrm>
+          <a:prstGeom prst="rect">
+            <a:avLst/>
+          </a:prstGeom>
+          <a:noFill/>
+        </p:spPr>
+        <p:txBody>
+          <a:bodyPr wrap="square">
+            <a:spAutoFit/>
+          </a:bodyPr>
+          <a:lstStyle/>
+          <a:p>
+            <a:pPr algn="l"/>
+            <a:r>
+              <a:rPr sz="1400" b="1">
+                <a:solidFill>
+                  <a:srgbClr val="222222"/>
+                </a:solidFill>
+                <a:latin typeface="Arial"/>
+                <a:ea typeface="AppleGothic"/>
+              </a:rPr>
+              <a:t>질문  support 안의 안전한 점만 고르는 방법이 strict extrapolation에서도 예측 범위와 정확도를 함께 유지하는가?</a:t>
+            </a:r>
+          </a:p>
+        </p:txBody>
+      </p:sp>
+      <p:graphicFrame>
+        <p:nvGraphicFramePr>
+          <p:cNvPr id="7" name="Table 6"/>
+          <p:cNvGraphicFramePr>
+            <a:graphicFrameLocks noGrp="1"/>
+          </p:cNvGraphicFramePr>
+          <p:nvPr/>
+        </p:nvGraphicFramePr>
+        <p:xfrm>
+          <a:off x="457200" y="1276350"/>
+          <a:ext cx="6858000" cy="3105150"/>
+        </p:xfrm>
+        <a:graphic>
+          <a:graphicData uri="http://schemas.openxmlformats.org/drawingml/2006/table">
+            <a:tbl>
+              <a:tblPr firstRow="1" bandRow="1">
+                <a:tableStyleId>{5C22544A-7EE6-4342-B048-85BDC9FD1C3A}</a:tableStyleId>
+              </a:tblPr>
+              <a:tblGrid>
+                <a:gridCol w="1371600"/>
+                <a:gridCol w="1371600"/>
+                <a:gridCol w="1371600"/>
+                <a:gridCol w="1371600"/>
+                <a:gridCol w="1371600"/>
+              </a:tblGrid>
+              <a:tr h="621030">
+                <a:tc>
+                  <a:txBody>
+                    <a:bodyPr/>
+                    <a:lstStyle/>
+                    <a:p>
+                      <a:pPr algn="ctr"/>
+                      <a:r>
+                        <a:rPr sz="1300" b="1">
+                          <a:solidFill>
+                            <a:srgbClr val="FFFFFF"/>
+                          </a:solidFill>
+                          <a:latin typeface="Arial"/>
+                          <a:ea typeface="AppleGothic"/>
+                        </a:rPr>
+                        <a:t>목표</a:t>
+                      </a:r>
+                    </a:p>
+                  </a:txBody>
+                  <a:tcPr anchor="ctr">
+                    <a:solidFill>
+                      <a:srgbClr val="222222"/>
+                    </a:solidFill>
+                  </a:tcPr>
+                </a:tc>
+                <a:tc>
+                  <a:txBody>
+                    <a:bodyPr/>
+                    <a:lstStyle/>
+                    <a:p>
+                      <a:pPr algn="ctr"/>
+                      <a:r>
+                        <a:rPr sz="1300" b="1">
+                          <a:solidFill>
+                            <a:srgbClr val="FFFFFF"/>
+                          </a:solidFill>
+                          <a:latin typeface="Arial"/>
+                          <a:ea typeface="AppleGothic"/>
+                        </a:rPr>
+                        <a:t>실제 평균 coverage</a:t>
+                      </a:r>
+                    </a:p>
+                  </a:txBody>
+                  <a:tcPr anchor="ctr">
+                    <a:solidFill>
+                      <a:srgbClr val="222222"/>
+                    </a:solidFill>
+                  </a:tcPr>
+                </a:tc>
+                <a:tc>
+                  <a:txBody>
+                    <a:bodyPr/>
+                    <a:lstStyle/>
+                    <a:p>
+                      <a:pPr algn="ctr"/>
+                      <a:r>
+                        <a:rPr sz="1300" b="1">
+                          <a:solidFill>
+                            <a:srgbClr val="FFFFFF"/>
+                          </a:solidFill>
+                          <a:latin typeface="Arial"/>
+                          <a:ea typeface="AppleGothic"/>
+                        </a:rPr>
+                        <a:t>PP-X nRMSE</a:t>
+                      </a:r>
+                    </a:p>
+                  </a:txBody>
+                  <a:tcPr anchor="ctr">
+                    <a:solidFill>
+                      <a:srgbClr val="222222"/>
+                    </a:solidFill>
+                  </a:tcPr>
+                </a:tc>
+                <a:tc>
+                  <a:txBody>
+                    <a:bodyPr/>
+                    <a:lstStyle/>
+                    <a:p>
+                      <a:pPr algn="ctr"/>
+                      <a:r>
+                        <a:rPr sz="1300" b="1">
+                          <a:solidFill>
+                            <a:srgbClr val="FFFFFF"/>
+                          </a:solidFill>
+                          <a:latin typeface="Arial"/>
+                          <a:ea typeface="AppleGothic"/>
+                        </a:rPr>
+                        <a:t>Selective NW</a:t>
+                      </a:r>
+                    </a:p>
+                  </a:txBody>
+                  <a:tcPr anchor="ctr">
+                    <a:solidFill>
+                      <a:srgbClr val="222222"/>
+                    </a:solidFill>
+                  </a:tcPr>
+                </a:tc>
+                <a:tc>
+                  <a:txBody>
+                    <a:bodyPr/>
+                    <a:lstStyle/>
+                    <a:p>
+                      <a:pPr algn="ctr"/>
+                      <a:r>
+                        <a:rPr sz="1300" b="1">
+                          <a:solidFill>
+                            <a:srgbClr val="FFFFFF"/>
+                          </a:solidFill>
+                          <a:latin typeface="Arial"/>
+                          <a:ea typeface="AppleGothic"/>
+                        </a:rPr>
+                        <a:t>승리</a:t>
+                      </a:r>
+                    </a:p>
+                  </a:txBody>
+                  <a:tcPr anchor="ctr">
+                    <a:solidFill>
+                      <a:srgbClr val="222222"/>
+                    </a:solidFill>
+                  </a:tcPr>
+                </a:tc>
+              </a:tr>
+              <a:tr h="621030">
+                <a:tc>
+                  <a:txBody>
+                    <a:bodyPr/>
+                    <a:lstStyle/>
+                    <a:p>
+                      <a:pPr algn="l"/>
+                      <a:r>
+                        <a:rPr sz="1300" b="1">
+                          <a:solidFill>
+                            <a:srgbClr val="222222"/>
+                          </a:solidFill>
+                          <a:latin typeface="Arial"/>
+                          <a:ea typeface="AppleGothic"/>
+                        </a:rPr>
+                        <a:t>25%</a:t>
+                      </a:r>
+                    </a:p>
+                  </a:txBody>
+                  <a:tcPr anchor="ctr">
+                    <a:solidFill>
+                      <a:srgbClr val="FFFFFF"/>
+                    </a:solidFill>
+                  </a:tcPr>
+                </a:tc>
+                <a:tc>
+                  <a:txBody>
+                    <a:bodyPr/>
+                    <a:lstStyle/>
+                    <a:p>
+                      <a:pPr algn="ctr"/>
+                      <a:r>
+                        <a:rPr sz="1300" b="0">
+                          <a:solidFill>
+                            <a:srgbClr val="222222"/>
+                          </a:solidFill>
+                          <a:latin typeface="Arial"/>
+                          <a:ea typeface="AppleGothic"/>
+                        </a:rPr>
+                        <a:t>5.8%</a:t>
+                      </a:r>
+                    </a:p>
+                  </a:txBody>
+                  <a:tcPr anchor="ctr">
+                    <a:solidFill>
+                      <a:srgbClr val="FFFFFF"/>
+                    </a:solidFill>
+                  </a:tcPr>
+                </a:tc>
+                <a:tc>
+                  <a:txBody>
+                    <a:bodyPr/>
+                    <a:lstStyle/>
+                    <a:p>
+                      <a:pPr algn="ctr"/>
+                      <a:r>
+                        <a:rPr sz="1300" b="0">
+                          <a:solidFill>
+                            <a:srgbClr val="222222"/>
+                          </a:solidFill>
+                          <a:latin typeface="Arial"/>
+                          <a:ea typeface="AppleGothic"/>
+                        </a:rPr>
+                        <a:t>0.272</a:t>
+                      </a:r>
+                    </a:p>
+                  </a:txBody>
+                  <a:tcPr anchor="ctr">
+                    <a:solidFill>
+                      <a:srgbClr val="FFFFFF"/>
+                    </a:solidFill>
+                  </a:tcPr>
+                </a:tc>
+                <a:tc>
+                  <a:txBody>
+                    <a:bodyPr/>
+                    <a:lstStyle/>
+                    <a:p>
+                      <a:pPr algn="ctr"/>
+                      <a:r>
+                        <a:rPr sz="1300" b="0">
+                          <a:solidFill>
+                            <a:srgbClr val="222222"/>
+                          </a:solidFill>
+                          <a:latin typeface="Arial"/>
+                          <a:ea typeface="AppleGothic"/>
+                        </a:rPr>
+                        <a:t>1.279</a:t>
+                      </a:r>
+                    </a:p>
+                  </a:txBody>
+                  <a:tcPr anchor="ctr">
+                    <a:solidFill>
+                      <a:srgbClr val="FFFFFF"/>
+                    </a:solidFill>
+                  </a:tcPr>
+                </a:tc>
+                <a:tc>
+                  <a:txBody>
+                    <a:bodyPr/>
+                    <a:lstStyle/>
+                    <a:p>
+                      <a:pPr algn="ctr"/>
+                      <a:r>
+                        <a:rPr sz="1300" b="0">
+                          <a:solidFill>
+                            <a:srgbClr val="222222"/>
+                          </a:solidFill>
+                          <a:latin typeface="Arial"/>
+                          <a:ea typeface="AppleGothic"/>
+                        </a:rPr>
+                        <a:t>5/5</a:t>
+                      </a:r>
+                    </a:p>
+                  </a:txBody>
+                  <a:tcPr anchor="ctr">
+                    <a:solidFill>
+                      <a:srgbClr val="FFFFFF"/>
+                    </a:solidFill>
+                  </a:tcPr>
+                </a:tc>
+              </a:tr>
+              <a:tr h="621030">
+                <a:tc>
+                  <a:txBody>
+                    <a:bodyPr/>
+                    <a:lstStyle/>
+                    <a:p>
+                      <a:pPr algn="l"/>
+                      <a:r>
+                        <a:rPr sz="1300" b="1">
+                          <a:solidFill>
+                            <a:srgbClr val="222222"/>
+                          </a:solidFill>
+                          <a:latin typeface="Arial"/>
+                          <a:ea typeface="AppleGothic"/>
+                        </a:rPr>
+                        <a:t>50%</a:t>
+                      </a:r>
+                    </a:p>
+                  </a:txBody>
+                  <a:tcPr anchor="ctr">
+                    <a:solidFill>
+                      <a:srgbClr val="F5F5F5"/>
+                    </a:solidFill>
+                  </a:tcPr>
+                </a:tc>
+                <a:tc>
+                  <a:txBody>
+                    <a:bodyPr/>
+                    <a:lstStyle/>
+                    <a:p>
+                      <a:pPr algn="ctr"/>
+                      <a:r>
+                        <a:rPr sz="1300" b="0">
+                          <a:solidFill>
+                            <a:srgbClr val="222222"/>
+                          </a:solidFill>
+                          <a:latin typeface="Arial"/>
+                          <a:ea typeface="AppleGothic"/>
+                        </a:rPr>
+                        <a:t>8.7%</a:t>
+                      </a:r>
+                    </a:p>
+                  </a:txBody>
+                  <a:tcPr anchor="ctr">
+                    <a:solidFill>
+                      <a:srgbClr val="F5F5F5"/>
+                    </a:solidFill>
+                  </a:tcPr>
+                </a:tc>
+                <a:tc>
+                  <a:txBody>
+                    <a:bodyPr/>
+                    <a:lstStyle/>
+                    <a:p>
+                      <a:pPr algn="ctr"/>
+                      <a:r>
+                        <a:rPr sz="1300" b="0">
+                          <a:solidFill>
+                            <a:srgbClr val="222222"/>
+                          </a:solidFill>
+                          <a:latin typeface="Arial"/>
+                          <a:ea typeface="AppleGothic"/>
+                        </a:rPr>
+                        <a:t>0.296</a:t>
+                      </a:r>
+                    </a:p>
+                  </a:txBody>
+                  <a:tcPr anchor="ctr">
+                    <a:solidFill>
+                      <a:srgbClr val="F5F5F5"/>
+                    </a:solidFill>
+                  </a:tcPr>
+                </a:tc>
+                <a:tc>
+                  <a:txBody>
+                    <a:bodyPr/>
+                    <a:lstStyle/>
+                    <a:p>
+                      <a:pPr algn="ctr"/>
+                      <a:r>
+                        <a:rPr sz="1300" b="0">
+                          <a:solidFill>
+                            <a:srgbClr val="222222"/>
+                          </a:solidFill>
+                          <a:latin typeface="Arial"/>
+                          <a:ea typeface="AppleGothic"/>
+                        </a:rPr>
+                        <a:t>1.275</a:t>
+                      </a:r>
+                    </a:p>
+                  </a:txBody>
+                  <a:tcPr anchor="ctr">
+                    <a:solidFill>
+                      <a:srgbClr val="F5F5F5"/>
+                    </a:solidFill>
+                  </a:tcPr>
+                </a:tc>
+                <a:tc>
+                  <a:txBody>
+                    <a:bodyPr/>
+                    <a:lstStyle/>
+                    <a:p>
+                      <a:pPr algn="ctr"/>
+                      <a:r>
+                        <a:rPr sz="1300" b="0">
+                          <a:solidFill>
+                            <a:srgbClr val="222222"/>
+                          </a:solidFill>
+                          <a:latin typeface="Arial"/>
+                          <a:ea typeface="AppleGothic"/>
+                        </a:rPr>
+                        <a:t>5/5</a:t>
+                      </a:r>
+                    </a:p>
+                  </a:txBody>
+                  <a:tcPr anchor="ctr">
+                    <a:solidFill>
+                      <a:srgbClr val="F5F5F5"/>
+                    </a:solidFill>
+                  </a:tcPr>
+                </a:tc>
+              </a:tr>
+              <a:tr h="621030">
+                <a:tc>
+                  <a:txBody>
+                    <a:bodyPr/>
+                    <a:lstStyle/>
+                    <a:p>
+                      <a:pPr algn="l"/>
+                      <a:r>
+                        <a:rPr sz="1300" b="1">
+                          <a:solidFill>
+                            <a:srgbClr val="222222"/>
+                          </a:solidFill>
+                          <a:latin typeface="Arial"/>
+                          <a:ea typeface="AppleGothic"/>
+                        </a:rPr>
+                        <a:t>75%</a:t>
+                      </a:r>
+                    </a:p>
+                  </a:txBody>
+                  <a:tcPr anchor="ctr">
+                    <a:solidFill>
+                      <a:srgbClr val="FFFFFF"/>
+                    </a:solidFill>
+                  </a:tcPr>
+                </a:tc>
+                <a:tc>
+                  <a:txBody>
+                    <a:bodyPr/>
+                    <a:lstStyle/>
+                    <a:p>
+                      <a:pPr algn="ctr"/>
+                      <a:r>
+                        <a:rPr sz="1300" b="0">
+                          <a:solidFill>
+                            <a:srgbClr val="222222"/>
+                          </a:solidFill>
+                          <a:latin typeface="Arial"/>
+                          <a:ea typeface="AppleGothic"/>
+                        </a:rPr>
+                        <a:t>11.5%</a:t>
+                      </a:r>
+                    </a:p>
+                  </a:txBody>
+                  <a:tcPr anchor="ctr">
+                    <a:solidFill>
+                      <a:srgbClr val="FFFFFF"/>
+                    </a:solidFill>
+                  </a:tcPr>
+                </a:tc>
+                <a:tc>
+                  <a:txBody>
+                    <a:bodyPr/>
+                    <a:lstStyle/>
+                    <a:p>
+                      <a:pPr algn="ctr"/>
+                      <a:r>
+                        <a:rPr sz="1300" b="0">
+                          <a:solidFill>
+                            <a:srgbClr val="222222"/>
+                          </a:solidFill>
+                          <a:latin typeface="Arial"/>
+                          <a:ea typeface="AppleGothic"/>
+                        </a:rPr>
+                        <a:t>0.303</a:t>
+                      </a:r>
+                    </a:p>
+                  </a:txBody>
+                  <a:tcPr anchor="ctr">
+                    <a:solidFill>
+                      <a:srgbClr val="FFFFFF"/>
+                    </a:solidFill>
+                  </a:tcPr>
+                </a:tc>
+                <a:tc>
+                  <a:txBody>
+                    <a:bodyPr/>
+                    <a:lstStyle/>
+                    <a:p>
+                      <a:pPr algn="ctr"/>
+                      <a:r>
+                        <a:rPr sz="1300" b="0">
+                          <a:solidFill>
+                            <a:srgbClr val="222222"/>
+                          </a:solidFill>
+                          <a:latin typeface="Arial"/>
+                          <a:ea typeface="AppleGothic"/>
+                        </a:rPr>
+                        <a:t>1.274</a:t>
+                      </a:r>
+                    </a:p>
+                  </a:txBody>
+                  <a:tcPr anchor="ctr">
+                    <a:solidFill>
+                      <a:srgbClr val="FFFFFF"/>
+                    </a:solidFill>
+                  </a:tcPr>
+                </a:tc>
+                <a:tc>
+                  <a:txBody>
+                    <a:bodyPr/>
+                    <a:lstStyle/>
+                    <a:p>
+                      <a:pPr algn="ctr"/>
+                      <a:r>
+                        <a:rPr sz="1300" b="0">
+                          <a:solidFill>
+                            <a:srgbClr val="222222"/>
+                          </a:solidFill>
+                          <a:latin typeface="Arial"/>
+                          <a:ea typeface="AppleGothic"/>
+                        </a:rPr>
+                        <a:t>5/5</a:t>
+                      </a:r>
+                    </a:p>
+                  </a:txBody>
+                  <a:tcPr anchor="ctr">
+                    <a:solidFill>
+                      <a:srgbClr val="FFFFFF"/>
+                    </a:solidFill>
+                  </a:tcPr>
+                </a:tc>
+              </a:tr>
+              <a:tr h="621030">
+                <a:tc>
+                  <a:txBody>
+                    <a:bodyPr/>
+                    <a:lstStyle/>
+                    <a:p>
+                      <a:pPr algn="l"/>
+                      <a:r>
+                        <a:rPr sz="1300" b="1">
+                          <a:solidFill>
+                            <a:srgbClr val="222222"/>
+                          </a:solidFill>
+                          <a:latin typeface="Arial"/>
+                          <a:ea typeface="AppleGothic"/>
+                        </a:rPr>
+                        <a:t>90%</a:t>
+                      </a:r>
+                    </a:p>
+                  </a:txBody>
+                  <a:tcPr anchor="ctr">
+                    <a:solidFill>
+                      <a:srgbClr val="F5F5F5"/>
+                    </a:solidFill>
+                  </a:tcPr>
+                </a:tc>
+                <a:tc>
+                  <a:txBody>
+                    <a:bodyPr/>
+                    <a:lstStyle/>
+                    <a:p>
+                      <a:pPr algn="ctr"/>
+                      <a:r>
+                        <a:rPr sz="1300" b="0">
+                          <a:solidFill>
+                            <a:srgbClr val="222222"/>
+                          </a:solidFill>
+                          <a:latin typeface="Arial"/>
+                          <a:ea typeface="AppleGothic"/>
+                        </a:rPr>
+                        <a:t>13.2%</a:t>
+                      </a:r>
+                    </a:p>
+                  </a:txBody>
+                  <a:tcPr anchor="ctr">
+                    <a:solidFill>
+                      <a:srgbClr val="F5F5F5"/>
+                    </a:solidFill>
+                  </a:tcPr>
+                </a:tc>
+                <a:tc>
+                  <a:txBody>
+                    <a:bodyPr/>
+                    <a:lstStyle/>
+                    <a:p>
+                      <a:pPr algn="ctr"/>
+                      <a:r>
+                        <a:rPr sz="1300" b="0">
+                          <a:solidFill>
+                            <a:srgbClr val="222222"/>
+                          </a:solidFill>
+                          <a:latin typeface="Arial"/>
+                          <a:ea typeface="AppleGothic"/>
+                        </a:rPr>
+                        <a:t>0.305</a:t>
+                      </a:r>
+                    </a:p>
+                  </a:txBody>
+                  <a:tcPr anchor="ctr">
+                    <a:solidFill>
+                      <a:srgbClr val="F5F5F5"/>
+                    </a:solidFill>
+                  </a:tcPr>
+                </a:tc>
+                <a:tc>
+                  <a:txBody>
+                    <a:bodyPr/>
+                    <a:lstStyle/>
+                    <a:p>
+                      <a:pPr algn="ctr"/>
+                      <a:r>
+                        <a:rPr sz="1300" b="0">
+                          <a:solidFill>
+                            <a:srgbClr val="222222"/>
+                          </a:solidFill>
+                          <a:latin typeface="Arial"/>
+                          <a:ea typeface="AppleGothic"/>
+                        </a:rPr>
+                        <a:t>1.266</a:t>
+                      </a:r>
+                    </a:p>
+                  </a:txBody>
+                  <a:tcPr anchor="ctr">
+                    <a:solidFill>
+                      <a:srgbClr val="F5F5F5"/>
+                    </a:solidFill>
+                  </a:tcPr>
+                </a:tc>
+                <a:tc>
+                  <a:txBody>
+                    <a:bodyPr/>
+                    <a:lstStyle/>
+                    <a:p>
+                      <a:pPr algn="ctr"/>
+                      <a:r>
+                        <a:rPr sz="1300" b="0">
+                          <a:solidFill>
+                            <a:srgbClr val="222222"/>
+                          </a:solidFill>
+                          <a:latin typeface="Arial"/>
+                          <a:ea typeface="AppleGothic"/>
+                        </a:rPr>
+                        <a:t>5/5</a:t>
+                      </a:r>
+                    </a:p>
+                  </a:txBody>
+                  <a:tcPr anchor="ctr">
+                    <a:solidFill>
+                      <a:srgbClr val="F5F5F5"/>
+                    </a:solidFill>
+                  </a:tcPr>
+                </a:tc>
+              </a:tr>
+            </a:tbl>
+          </a:graphicData>
+        </a:graphic>
+      </p:graphicFrame>
+      <p:sp>
+        <p:nvSpPr>
+          <p:cNvPr id="8" name="Rounded Rectangle 7"/>
+          <p:cNvSpPr/>
+          <p:nvPr/>
+        </p:nvSpPr>
+        <p:spPr>
+          <a:xfrm>
+            <a:off x="7620000" y="1276350"/>
+            <a:ext cx="4114800" cy="1371600"/>
+          </a:xfrm>
+          <a:prstGeom prst="roundRect">
+            <a:avLst>
+              <a:gd name="adj" fmla="val 12000"/>
+            </a:avLst>
+          </a:prstGeom>
+          <a:solidFill>
+            <a:srgbClr val="FDF4E3"/>
+          </a:solidFill>
+          <a:ln w="15875">
+            <a:solidFill>
+              <a:srgbClr val="E69F00"/>
+            </a:solidFill>
+          </a:ln>
+        </p:spPr>
+        <p:style>
+          <a:lnRef idx="1">
+            <a:schemeClr val="accent1"/>
+          </a:lnRef>
+          <a:fillRef idx="3">
+            <a:schemeClr val="accent1"/>
+          </a:fillRef>
+          <a:effectRef idx="2">
+            <a:schemeClr val="accent1"/>
+          </a:effectRef>
+          <a:fontRef idx="minor">
+            <a:schemeClr val="lt1"/>
+          </a:fontRef>
+        </p:style>
+        <p:txBody>
+          <a:bodyPr rtlCol="0" anchor="ctr"/>
+          <a:lstStyle/>
+          <a:p>
+            <a:pPr algn="ctr"/>
+          </a:p>
+        </p:txBody>
+      </p:sp>
+      <p:sp>
+        <p:nvSpPr>
+          <p:cNvPr id="9" name="TextBox 8"/>
+          <p:cNvSpPr txBox="1"/>
+          <p:nvPr/>
+        </p:nvSpPr>
+        <p:spPr>
+          <a:xfrm>
+            <a:off x="7829550" y="1466850"/>
+            <a:ext cx="3695700" cy="285750"/>
+          </a:xfrm>
+          <a:prstGeom prst="rect">
+            <a:avLst/>
+          </a:prstGeom>
+          <a:noFill/>
+        </p:spPr>
+        <p:txBody>
+          <a:bodyPr wrap="square">
+            <a:spAutoFit/>
+          </a:bodyPr>
+          <a:lstStyle/>
+          <a:p>
+            <a:pPr algn="ctr"/>
+            <a:r>
+              <a:rPr sz="1600" b="1">
+                <a:solidFill>
+                  <a:srgbClr val="E69F00"/>
+                </a:solidFill>
+                <a:latin typeface="Arial"/>
+                <a:ea typeface="AppleGothic"/>
+              </a:rPr>
+              <a:t>Coverage 결과</a:t>
+            </a:r>
+          </a:p>
+        </p:txBody>
+      </p:sp>
+      <p:sp>
+        <p:nvSpPr>
+          <p:cNvPr id="10" name="TextBox 9"/>
+          <p:cNvSpPr txBox="1"/>
+          <p:nvPr/>
+        </p:nvSpPr>
+        <p:spPr>
+          <a:xfrm>
+            <a:off x="7848600" y="1885950"/>
+            <a:ext cx="3657600" cy="552450"/>
+          </a:xfrm>
+          <a:prstGeom prst="rect">
+            <a:avLst/>
+          </a:prstGeom>
+          <a:noFill/>
+        </p:spPr>
+        <p:txBody>
+          <a:bodyPr wrap="square">
+            <a:spAutoFit/>
+          </a:bodyPr>
+          <a:lstStyle/>
+          <a:p>
+            <a:pPr algn="ctr"/>
+            <a:r>
+              <a:rPr sz="1400" b="1">
+                <a:solidFill>
+                  <a:srgbClr val="222222"/>
+                </a:solidFill>
+                <a:latin typeface="Arial"/>
+                <a:ea typeface="AppleGothic"/>
+              </a:rPr>
+              <a:t>4/9 setting은 전부 거절</a:t>
+            </a:r>
+          </a:p>
+          <a:p>
+            <a:pPr algn="ctr"/>
+            <a:r>
+              <a:rPr sz="1400" b="1">
+                <a:solidFill>
+                  <a:srgbClr val="222222"/>
+                </a:solidFill>
+                <a:latin typeface="Arial"/>
+                <a:ea typeface="AppleGothic"/>
+              </a:rPr>
+              <a:t>N-CMAPSS만 100% admissible</a:t>
+            </a:r>
+          </a:p>
+        </p:txBody>
+      </p:sp>
+      <p:sp>
+        <p:nvSpPr>
+          <p:cNvPr id="11" name="Rounded Rectangle 10"/>
+          <p:cNvSpPr/>
+          <p:nvPr/>
+        </p:nvSpPr>
+        <p:spPr>
+          <a:xfrm>
+            <a:off x="7620000" y="2876550"/>
+            <a:ext cx="4114800" cy="1504950"/>
+          </a:xfrm>
+          <a:prstGeom prst="roundRect">
+            <a:avLst>
+              <a:gd name="adj" fmla="val 12000"/>
+            </a:avLst>
+          </a:prstGeom>
+          <a:solidFill>
+            <a:srgbClr val="E8F1F8"/>
+          </a:solidFill>
+          <a:ln w="15875">
+            <a:solidFill>
+              <a:srgbClr val="0072B2"/>
+            </a:solidFill>
+          </a:ln>
+        </p:spPr>
+        <p:style>
+          <a:lnRef idx="1">
+            <a:schemeClr val="accent1"/>
+          </a:lnRef>
+          <a:fillRef idx="3">
+            <a:schemeClr val="accent1"/>
+          </a:fillRef>
+          <a:effectRef idx="2">
+            <a:schemeClr val="accent1"/>
+          </a:effectRef>
+          <a:fontRef idx="minor">
+            <a:schemeClr val="lt1"/>
+          </a:fontRef>
+        </p:style>
+        <p:txBody>
+          <a:bodyPr rtlCol="0" anchor="ctr"/>
+          <a:lstStyle/>
+          <a:p>
+            <a:pPr algn="ctr"/>
+          </a:p>
+        </p:txBody>
+      </p:sp>
+      <p:sp>
+        <p:nvSpPr>
+          <p:cNvPr id="12" name="TextBox 11"/>
+          <p:cNvSpPr txBox="1"/>
+          <p:nvPr/>
+        </p:nvSpPr>
+        <p:spPr>
+          <a:xfrm>
+            <a:off x="7829550" y="3067050"/>
+            <a:ext cx="3695700" cy="285750"/>
+          </a:xfrm>
+          <a:prstGeom prst="rect">
+            <a:avLst/>
+          </a:prstGeom>
+          <a:noFill/>
+        </p:spPr>
+        <p:txBody>
+          <a:bodyPr wrap="square">
+            <a:spAutoFit/>
+          </a:bodyPr>
+          <a:lstStyle/>
+          <a:p>
+            <a:pPr algn="ctr"/>
+            <a:r>
+              <a:rPr sz="1600" b="1">
+                <a:solidFill>
+                  <a:srgbClr val="0072B2"/>
+                </a:solidFill>
+                <a:latin typeface="Arial"/>
+                <a:ea typeface="AppleGothic"/>
+              </a:rPr>
+              <a:t>동일 행 수에서</a:t>
+            </a:r>
+          </a:p>
+        </p:txBody>
+      </p:sp>
+      <p:sp>
+        <p:nvSpPr>
+          <p:cNvPr id="13" name="TextBox 12"/>
+          <p:cNvSpPr txBox="1"/>
+          <p:nvPr/>
+        </p:nvSpPr>
+        <p:spPr>
+          <a:xfrm>
+            <a:off x="7848600" y="3486150"/>
+            <a:ext cx="3657600" cy="685800"/>
+          </a:xfrm>
+          <a:prstGeom prst="rect">
+            <a:avLst/>
+          </a:prstGeom>
+          <a:noFill/>
+        </p:spPr>
+        <p:txBody>
+          <a:bodyPr wrap="square">
+            <a:spAutoFit/>
+          </a:bodyPr>
+          <a:lstStyle/>
+          <a:p>
+            <a:pPr algn="ctr"/>
+            <a:r>
+              <a:rPr sz="1300" b="1">
+                <a:solidFill>
+                  <a:srgbClr val="222222"/>
+                </a:solidFill>
+                <a:latin typeface="Arial"/>
+                <a:ea typeface="AppleGothic"/>
+              </a:rPr>
+              <a:t>PP-X가 비교 가능한 5/5에서 우세</a:t>
+            </a:r>
+          </a:p>
+          <a:p>
+            <a:pPr algn="ctr"/>
+            <a:r>
+              <a:rPr sz="1300" b="1">
+                <a:solidFill>
+                  <a:srgbClr val="222222"/>
+                </a:solidFill>
+                <a:latin typeface="Arial"/>
+                <a:ea typeface="AppleGothic"/>
+              </a:rPr>
+              <a:t>양측 exact p=.0625</a:t>
+            </a:r>
+          </a:p>
+          <a:p>
+            <a:pPr algn="ctr"/>
+            <a:r>
+              <a:rPr sz="1300" b="1">
+                <a:solidFill>
+                  <a:srgbClr val="222222"/>
+                </a:solidFill>
+                <a:latin typeface="Arial"/>
+                <a:ea typeface="AppleGothic"/>
+              </a:rPr>
+              <a:t>(n=5의 최소 양측 p)</a:t>
+            </a:r>
+          </a:p>
+        </p:txBody>
+      </p:sp>
+      <p:sp>
+        <p:nvSpPr>
+          <p:cNvPr id="14" name="Rounded Rectangle 13"/>
+          <p:cNvSpPr/>
+          <p:nvPr/>
+        </p:nvSpPr>
+        <p:spPr>
+          <a:xfrm>
+            <a:off x="457200" y="4762500"/>
+            <a:ext cx="11277600" cy="819150"/>
+          </a:xfrm>
+          <a:prstGeom prst="roundRect">
+            <a:avLst>
+              <a:gd name="adj" fmla="val 12000"/>
+            </a:avLst>
+          </a:prstGeom>
+          <a:solidFill>
+            <a:srgbClr val="222222"/>
+          </a:solidFill>
+          <a:ln>
+            <a:noFill/>
+          </a:ln>
+        </p:spPr>
+        <p:style>
+          <a:lnRef idx="1">
+            <a:schemeClr val="accent1"/>
+          </a:lnRef>
+          <a:fillRef idx="3">
+            <a:schemeClr val="accent1"/>
+          </a:fillRef>
+          <a:effectRef idx="2">
+            <a:schemeClr val="accent1"/>
+          </a:effectRef>
+          <a:fontRef idx="minor">
+            <a:schemeClr val="lt1"/>
+          </a:fontRef>
+        </p:style>
+        <p:txBody>
+          <a:bodyPr rtlCol="0" anchor="ctr"/>
+          <a:lstStyle/>
+          <a:p>
+            <a:pPr algn="ctr"/>
+          </a:p>
+        </p:txBody>
+      </p:sp>
+      <p:sp>
+        <p:nvSpPr>
+          <p:cNvPr id="15" name="TextBox 14"/>
+          <p:cNvSpPr txBox="1"/>
+          <p:nvPr/>
+        </p:nvSpPr>
+        <p:spPr>
+          <a:xfrm>
+            <a:off x="666750" y="4895850"/>
+            <a:ext cx="10858500" cy="552450"/>
+          </a:xfrm>
+          <a:prstGeom prst="rect">
+            <a:avLst/>
+          </a:prstGeom>
+          <a:noFill/>
+        </p:spPr>
+        <p:txBody>
+          <a:bodyPr wrap="square">
+            <a:spAutoFit/>
+          </a:bodyPr>
+          <a:lstStyle/>
+          <a:p>
+            <a:pPr algn="ctr"/>
+            <a:r>
+              <a:rPr sz="1400" b="1">
+                <a:solidFill>
+                  <a:srgbClr val="FFFFFF"/>
+                </a:solidFill>
+                <a:latin typeface="Arial"/>
+                <a:ea typeface="AppleGothic"/>
+              </a:rPr>
+              <a:t>의미  Selective Regression은 support가 희박하면 예측을 버린다. PP-X는 지지된 prior-residual 경로로 외삽 coverage를 유지하면서, 같은 coverage에서도 accepted risk를 낮췄다.</a:t>
+            </a:r>
+          </a:p>
+        </p:txBody>
+      </p:sp>
+      <p:sp>
+        <p:nvSpPr>
+          <p:cNvPr id="16" name="TextBox 15"/>
+          <p:cNvSpPr txBox="1"/>
+          <p:nvPr/>
+        </p:nvSpPr>
+        <p:spPr>
+          <a:xfrm>
+            <a:off x="457200" y="5810250"/>
+            <a:ext cx="11277600" cy="247650"/>
+          </a:xfrm>
+          <a:prstGeom prst="rect">
+            <a:avLst/>
+          </a:prstGeom>
+          <a:noFill/>
+        </p:spPr>
+        <p:txBody>
+          <a:bodyPr wrap="square">
+            <a:spAutoFit/>
+          </a:bodyPr>
+          <a:lstStyle/>
+          <a:p>
+            <a:pPr algn="ctr"/>
+            <a:r>
+              <a:rPr sz="1000" b="0">
+                <a:solidFill>
+                  <a:srgbClr val="666666"/>
+                </a:solidFill>
+                <a:latin typeface="Arial"/>
+                <a:ea typeface="AppleGothic"/>
+              </a:rPr>
+              <a:t>9개 메인 setting · 동일 split · test label은 최종 risk 계산에만 사용</a:t>
+            </a:r>
+          </a:p>
+        </p:txBody>
+      </p:sp>
+      <p:cxnSp>
+        <p:nvCxnSpPr>
+          <p:cNvPr id="17" name="Connector 16"/>
+          <p:cNvCxnSpPr/>
+          <p:nvPr/>
+        </p:nvCxnSpPr>
+        <p:spPr>
+          <a:xfrm>
+            <a:off x="457200" y="6477000"/>
+            <a:ext cx="11277600" cy="0"/>
+          </a:xfrm>
+          <a:prstGeom prst="line">
+            <a:avLst/>
+          </a:prstGeom>
+          <a:ln w="9525">
+            <a:solidFill>
+              <a:srgbClr val="E8E8E8"/>
+            </a:solidFill>
+          </a:ln>
+        </p:spPr>
+        <p:style>
+          <a:lnRef idx="2">
+            <a:schemeClr val="accent1"/>
+          </a:lnRef>
+          <a:fillRef idx="0">
+            <a:schemeClr val="accent1"/>
+          </a:fillRef>
+          <a:effectRef idx="1">
+            <a:schemeClr val="accent1"/>
+          </a:effectRef>
+          <a:fontRef idx="minor">
+            <a:schemeClr val="tx1"/>
+          </a:fontRef>
+        </p:style>
+      </p:cxnSp>
+      <p:sp>
+        <p:nvSpPr>
+          <p:cNvPr id="18" name="TextBox 17"/>
+          <p:cNvSpPr txBox="1"/>
+          <p:nvPr/>
+        </p:nvSpPr>
+        <p:spPr>
+          <a:xfrm>
+            <a:off x="457200" y="6534150"/>
+            <a:ext cx="7620000" cy="133350"/>
+          </a:xfrm>
+          <a:prstGeom prst="rect">
+            <a:avLst/>
+          </a:prstGeom>
+          <a:noFill/>
+        </p:spPr>
+        <p:txBody>
+          <a:bodyPr wrap="square">
+            <a:spAutoFit/>
+          </a:bodyPr>
+          <a:lstStyle/>
+          <a:p>
+            <a:pPr algn="l"/>
+            <a:r>
+              <a:rPr sz="900" b="0">
+                <a:solidFill>
+                  <a:srgbClr val="666666"/>
+                </a:solidFill>
+                <a:latin typeface="Arial"/>
+                <a:ea typeface="AppleGothic"/>
+              </a:rPr>
+              <a:t>SPS Lab  ·  Prior-Adaptive Extrapolation  ·  PP-X</a:t>
+            </a:r>
+          </a:p>
+        </p:txBody>
+      </p:sp>
+      <p:sp>
+        <p:nvSpPr>
+          <p:cNvPr id="19" name="TextBox 18"/>
+          <p:cNvSpPr txBox="1"/>
+          <p:nvPr/>
+        </p:nvSpPr>
+        <p:spPr>
+          <a:xfrm>
+            <a:off x="10477500" y="6515100"/>
+            <a:ext cx="952500" cy="152400"/>
+          </a:xfrm>
+          <a:prstGeom prst="rect">
+            <a:avLst/>
+          </a:prstGeom>
+          <a:noFill/>
+        </p:spPr>
+        <p:txBody>
+          <a:bodyPr wrap="square">
+            <a:spAutoFit/>
+          </a:bodyPr>
+          <a:lstStyle/>
+          <a:p>
+            <a:pPr algn="r"/>
+            <a:r>
+              <a:rPr sz="1000" b="1">
+                <a:solidFill>
+                  <a:srgbClr val="666666"/>
+                </a:solidFill>
+                <a:latin typeface="Arial"/>
+                <a:ea typeface="AppleGothic"/>
+              </a:rPr>
+              <a:t>24/40</a:t>
             </a:r>
           </a:p>
         </p:txBody>
@@ -36707,7 +38060,7 @@
                 <a:latin typeface="Arial"/>
                 <a:ea typeface="AppleGothic"/>
               </a:rPr>
-              <a:t>5/39</a:t>
+              <a:t>6/40</a:t>
             </a:r>
           </a:p>
         </p:txBody>
@@ -38293,7 +39646,7 @@
                 <a:latin typeface="Arial"/>
                 <a:ea typeface="AppleGothic"/>
               </a:rPr>
-              <a:t>6/39</a:t>
+              <a:t>23/40</a:t>
             </a:r>
           </a:p>
         </p:txBody>
@@ -39554,7 +40907,7 @@
                 <a:latin typeface="Arial"/>
                 <a:ea typeface="AppleGothic"/>
               </a:rPr>
-              <a:t>7/39</a:t>
+              <a:t>26/40</a:t>
             </a:r>
           </a:p>
         </p:txBody>
@@ -39694,7 +41047,7 @@
                 <a:latin typeface="Arial"/>
                 <a:ea typeface="AppleGothic"/>
               </a:rPr>
-              <a:t>연구 루트</a:t>
+              <a:t>연구 루트 — 식의 근거에 따라 두 경로로 간다</a:t>
             </a:r>
           </a:p>
         </p:txBody>
@@ -39730,7 +41083,7 @@
                 <a:latin typeface="Arial"/>
                 <a:ea typeface="AppleGothic"/>
               </a:rPr>
-              <a:t>그래서 후보식이 정당화되는지에 따라 경로를 나눈다</a:t>
+              <a:t>식이 없거나 약한 prior만 있으면 PP-X, 적용 가능한 식이 정당화되면 PAE로 확장한다.</a:t>
             </a:r>
           </a:p>
         </p:txBody>
@@ -40654,7 +42007,7 @@
                 <a:latin typeface="Arial"/>
                 <a:ea typeface="AppleGothic"/>
               </a:rPr>
-              <a:t>equation-free</a:t>
+              <a:t>equation-unavailable · weak-prior route</a:t>
             </a:r>
           </a:p>
         </p:txBody>
@@ -40979,7 +42332,7 @@
                 <a:latin typeface="Arial"/>
                 <a:ea typeface="AppleGothic"/>
               </a:rPr>
-              <a:t>equation-aware</a:t>
+              <a:t>validated-equation route</a:t>
             </a:r>
           </a:p>
         </p:txBody>
@@ -41435,7 +42788,7 @@
                 <a:latin typeface="Arial"/>
                 <a:ea typeface="AppleGothic"/>
               </a:rPr>
-              <a:t>8/39</a:t>
+              <a:t>4/40</a:t>
             </a:r>
           </a:p>
         </p:txBody>
@@ -42329,7 +43682,7 @@
                 <a:latin typeface="Arial"/>
                 <a:ea typeface="AppleGothic"/>
               </a:rPr>
-              <a:t>9/39</a:t>
+              <a:t>7/40</a:t>
             </a:r>
           </a:p>
         </p:txBody>

</xml_diff>

<commit_message>
Align PPT contributions with three-claim narrative
Replace the four-block contribution slide with the fixed contract, execution, and equal-coverage claims.

Co-authored-by: Cursor <cursoragent@cursor.com>
</commit_message>
<xml_diff>
--- a/ppt/PP-X_Research_Detailed_v2.pptx
+++ b/ppt/PP-X_Research_Detailed_v2.pptx
@@ -34288,7 +34288,7 @@
                 <a:latin typeface="Arial"/>
                 <a:ea typeface="AppleGothic"/>
               </a:rPr>
-              <a:t>연구 기여 — 새 블록 하나보다 ‘가정을 실행하는 규칙’을 제안한다</a:t>
+              <a:t>연구 기여 — execution architecture로 고정한다</a:t>
             </a:r>
           </a:p>
         </p:txBody>
@@ -34324,7 +34324,7 @@
                 <a:latin typeface="Arial"/>
                 <a:ea typeface="AppleGothic"/>
               </a:rPr>
-              <a:t>개별 요소의 최초성이 아니라, 외삽 가정의 선언·학습·승인·거절을 하나의 검증 가능한 절차로 결합한다.</a:t>
+              <a:t>PP-X는 universal neural predictor가 아니라, prior의 선언·승인·실행·거절을 검증 가능한 절차로 만든 구조다.</a:t>
             </a:r>
           </a:p>
         </p:txBody>
@@ -34338,7 +34338,7 @@
         <p:spPr>
           <a:xfrm>
             <a:off x="457200" y="1123950"/>
-            <a:ext cx="2647950" cy="2990850"/>
+            <a:ext cx="3657600" cy="2990850"/>
           </a:xfrm>
           <a:prstGeom prst="roundRect">
             <a:avLst>
@@ -34385,7 +34385,7 @@
         <p:spPr>
           <a:xfrm>
             <a:off x="628650" y="1352550"/>
-            <a:ext cx="2305050" cy="285750"/>
+            <a:ext cx="3314700" cy="438150"/>
           </a:xfrm>
           <a:prstGeom prst="rect">
             <a:avLst/>
@@ -34407,7 +34407,7 @@
                 <a:latin typeface="Arial"/>
                 <a:ea typeface="AppleGothic"/>
               </a:rPr>
-              <a:t>C1  Typed contract</a:t>
+              <a:t>C1  Contract-conditioned model</a:t>
             </a:r>
           </a:p>
         </p:txBody>
@@ -34420,8 +34420,8 @@
         </p:nvCxnSpPr>
         <p:spPr>
           <a:xfrm>
-            <a:off x="685800" y="1828800"/>
-            <a:ext cx="2190750" cy="0"/>
+            <a:off x="723900" y="2000250"/>
+            <a:ext cx="3124200" cy="0"/>
           </a:xfrm>
           <a:prstGeom prst="line">
             <a:avLst/>
@@ -34455,8 +34455,8 @@
         </p:nvSpPr>
         <p:spPr>
           <a:xfrm>
-            <a:off x="628650" y="2133600"/>
-            <a:ext cx="2305050" cy="1314450"/>
+            <a:off x="685800" y="2247900"/>
+            <a:ext cx="3200400" cy="1524000"/>
           </a:xfrm>
           <a:prstGeom prst="rect">
             <a:avLst/>
@@ -34471,40 +34471,53 @@
           <a:p>
             <a:pPr algn="ctr"/>
             <a:r>
-              <a:rPr sz="1300" b="0">
+              <a:rPr sz="1400" b="0">
                 <a:solidFill>
                   <a:srgbClr val="222222"/>
                 </a:solidFill>
                 <a:latin typeface="Arial"/>
                 <a:ea typeface="AppleGothic"/>
               </a:rPr>
-              <a:t>test 결과를 보기 전에</a:t>
+              <a:t>경계 · history · support · causal</a:t>
             </a:r>
           </a:p>
           <a:p>
             <a:pPr algn="ctr"/>
             <a:r>
-              <a:rPr sz="1300" b="0">
+              <a:rPr sz="1400" b="0">
                 <a:solidFill>
                   <a:srgbClr val="222222"/>
                 </a:solidFill>
                 <a:latin typeface="Arial"/>
                 <a:ea typeface="AppleGothic"/>
               </a:rPr>
-              <a:t>경계 · unit · causal X ·</a:t>
+              <a:t>정보로 허용 prior를 선언하고</a:t>
             </a:r>
           </a:p>
           <a:p>
             <a:pPr algn="ctr"/>
             <a:r>
-              <a:rPr sz="1300" b="0">
+              <a:rPr sz="1400" b="0">
                 <a:solidFill>
                   <a:srgbClr val="222222"/>
                 </a:solidFill>
                 <a:latin typeface="Arial"/>
                 <a:ea typeface="AppleGothic"/>
               </a:rPr>
-              <a:t>허용 prior · fallback 선언</a:t>
+              <a:t>frozen prior 주변의 bounded</a:t>
+            </a:r>
+          </a:p>
+          <a:p>
+            <a:pPr algn="ctr"/>
+            <a:r>
+              <a:rPr sz="1400" b="0">
+                <a:solidFill>
+                  <a:srgbClr val="222222"/>
+                </a:solidFill>
+                <a:latin typeface="Arial"/>
+                <a:ea typeface="AppleGothic"/>
+              </a:rPr>
+              <a:t>causal residual만 학습</a:t>
             </a:r>
           </a:p>
         </p:txBody>
@@ -34517,8 +34530,201 @@
         </p:nvSpPr>
         <p:spPr>
           <a:xfrm>
-            <a:off x="3333750" y="1123950"/>
-            <a:ext cx="2647950" cy="2990850"/>
+            <a:off x="4267200" y="1123950"/>
+            <a:ext cx="3657600" cy="2990850"/>
+          </a:xfrm>
+          <a:prstGeom prst="roundRect">
+            <a:avLst>
+              <a:gd name="adj" fmla="val 12000"/>
+            </a:avLst>
+          </a:prstGeom>
+          <a:solidFill>
+            <a:srgbClr val="FDF4E3"/>
+          </a:solidFill>
+          <a:ln w="15875">
+            <a:solidFill>
+              <a:srgbClr val="E69F00"/>
+            </a:solidFill>
+          </a:ln>
+        </p:spPr>
+        <p:style>
+          <a:lnRef idx="1">
+            <a:schemeClr val="accent1"/>
+          </a:lnRef>
+          <a:fillRef idx="3">
+            <a:schemeClr val="accent1"/>
+          </a:fillRef>
+          <a:effectRef idx="2">
+            <a:schemeClr val="accent1"/>
+          </a:effectRef>
+          <a:fontRef idx="minor">
+            <a:schemeClr val="lt1"/>
+          </a:fontRef>
+        </p:style>
+        <p:txBody>
+          <a:bodyPr rtlCol="0" anchor="ctr"/>
+          <a:lstStyle/>
+          <a:p>
+            <a:pPr algn="ctr"/>
+          </a:p>
+        </p:txBody>
+      </p:sp>
+      <p:sp>
+        <p:nvSpPr>
+          <p:cNvPr id="11" name="TextBox 10"/>
+          <p:cNvSpPr txBox="1"/>
+          <p:nvPr/>
+        </p:nvSpPr>
+        <p:spPr>
+          <a:xfrm>
+            <a:off x="4438650" y="1352550"/>
+            <a:ext cx="3314700" cy="438150"/>
+          </a:xfrm>
+          <a:prstGeom prst="rect">
+            <a:avLst/>
+          </a:prstGeom>
+          <a:noFill/>
+        </p:spPr>
+        <p:txBody>
+          <a:bodyPr wrap="square">
+            <a:spAutoFit/>
+          </a:bodyPr>
+          <a:lstStyle/>
+          <a:p>
+            <a:pPr algn="ctr"/>
+            <a:r>
+              <a:rPr sz="1500" b="1">
+                <a:solidFill>
+                  <a:srgbClr val="E69F00"/>
+                </a:solidFill>
+                <a:latin typeface="Arial"/>
+                <a:ea typeface="AppleGothic"/>
+              </a:rPr>
+              <a:t>C2  Validation-approved execution</a:t>
+            </a:r>
+          </a:p>
+        </p:txBody>
+      </p:sp>
+      <p:cxnSp>
+        <p:nvCxnSpPr>
+          <p:cNvPr id="12" name="Connector 11"/>
+          <p:cNvCxnSpPr/>
+          <p:nvPr/>
+        </p:nvCxnSpPr>
+        <p:spPr>
+          <a:xfrm>
+            <a:off x="4533900" y="2000250"/>
+            <a:ext cx="3124200" cy="0"/>
+          </a:xfrm>
+          <a:prstGeom prst="line">
+            <a:avLst/>
+          </a:prstGeom>
+          <a:ln w="15875">
+            <a:solidFill>
+              <a:srgbClr val="E8E8E8"/>
+            </a:solidFill>
+          </a:ln>
+        </p:spPr>
+        <p:style>
+          <a:lnRef idx="2">
+            <a:schemeClr val="accent1"/>
+          </a:lnRef>
+          <a:fillRef idx="0">
+            <a:schemeClr val="accent1"/>
+          </a:fillRef>
+          <a:effectRef idx="1">
+            <a:schemeClr val="accent1"/>
+          </a:effectRef>
+          <a:fontRef idx="minor">
+            <a:schemeClr val="tx1"/>
+          </a:fontRef>
+        </p:style>
+      </p:cxnSp>
+      <p:sp>
+        <p:nvSpPr>
+          <p:cNvPr id="13" name="TextBox 12"/>
+          <p:cNvSpPr txBox="1"/>
+          <p:nvPr/>
+        </p:nvSpPr>
+        <p:spPr>
+          <a:xfrm>
+            <a:off x="4495800" y="2247900"/>
+            <a:ext cx="3200400" cy="1524000"/>
+          </a:xfrm>
+          <a:prstGeom prst="rect">
+            <a:avLst/>
+          </a:prstGeom>
+          <a:noFill/>
+        </p:spPr>
+        <p:txBody>
+          <a:bodyPr wrap="square">
+            <a:spAutoFit/>
+          </a:bodyPr>
+          <a:lstStyle/>
+          <a:p>
+            <a:pPr algn="ctr"/>
+            <a:r>
+              <a:rPr sz="1400" b="0">
+                <a:solidFill>
+                  <a:srgbClr val="222222"/>
+                </a:solidFill>
+                <a:latin typeface="Arial"/>
+                <a:ea typeface="AppleGothic"/>
+              </a:rPr>
+              <a:t>bound · dual-scale · transport · history를</a:t>
+            </a:r>
+          </a:p>
+          <a:p>
+            <a:pPr algn="ctr"/>
+            <a:r>
+              <a:rPr sz="1400" b="0">
+                <a:solidFill>
+                  <a:srgbClr val="222222"/>
+                </a:solidFill>
+                <a:latin typeface="Arial"/>
+                <a:ea typeface="AppleGothic"/>
+              </a:rPr>
+              <a:t>전역으로 켜지 않고</a:t>
+            </a:r>
+          </a:p>
+          <a:p>
+            <a:pPr algn="ctr"/>
+            <a:r>
+              <a:rPr sz="1400" b="0">
+                <a:solidFill>
+                  <a:srgbClr val="222222"/>
+                </a:solidFill>
+                <a:latin typeface="Arial"/>
+                <a:ea typeface="AppleGothic"/>
+              </a:rPr>
+              <a:t>validation이 지지한 executor만 실행</a:t>
+            </a:r>
+          </a:p>
+          <a:p>
+            <a:pPr algn="ctr"/>
+            <a:r>
+              <a:rPr sz="1400" b="0">
+                <a:solidFill>
+                  <a:srgbClr val="222222"/>
+                </a:solidFill>
+                <a:latin typeface="Arial"/>
+                <a:ea typeface="AppleGothic"/>
+              </a:rPr>
+              <a:t>반례에서는 거절 / fallback</a:t>
+            </a:r>
+          </a:p>
+        </p:txBody>
+      </p:sp>
+      <p:sp>
+        <p:nvSpPr>
+          <p:cNvPr id="14" name="Rounded Rectangle 13"/>
+          <p:cNvSpPr/>
+          <p:nvPr/>
+        </p:nvSpPr>
+        <p:spPr>
+          <a:xfrm>
+            <a:off x="8077200" y="1123950"/>
+            <a:ext cx="3657600" cy="2990850"/>
           </a:xfrm>
           <a:prstGeom prst="roundRect">
             <a:avLst>
@@ -34558,14 +34764,14 @@
       </p:sp>
       <p:sp>
         <p:nvSpPr>
-          <p:cNvPr id="11" name="TextBox 10"/>
+          <p:cNvPr id="15" name="TextBox 14"/>
           <p:cNvSpPr txBox="1"/>
           <p:nvPr/>
         </p:nvSpPr>
         <p:spPr>
           <a:xfrm>
-            <a:off x="3505200" y="1352550"/>
-            <a:ext cx="2305050" cy="285750"/>
+            <a:off x="8248650" y="1352550"/>
+            <a:ext cx="3314700" cy="438150"/>
           </a:xfrm>
           <a:prstGeom prst="rect">
             <a:avLst/>
@@ -34587,21 +34793,21 @@
                 <a:latin typeface="Arial"/>
                 <a:ea typeface="AppleGothic"/>
               </a:rPr>
-              <a:t>C2  Prior-residual core</a:t>
+              <a:t>C3  Equal-coverage evidence</a:t>
             </a:r>
           </a:p>
         </p:txBody>
       </p:sp>
       <p:cxnSp>
         <p:nvCxnSpPr>
-          <p:cNvPr id="12" name="Connector 11"/>
+          <p:cNvPr id="16" name="Connector 15"/>
           <p:cNvCxnSpPr/>
           <p:nvPr/>
         </p:nvCxnSpPr>
         <p:spPr>
           <a:xfrm>
-            <a:off x="3562350" y="1828800"/>
-            <a:ext cx="2190750" cy="0"/>
+            <a:off x="8343900" y="2000250"/>
+            <a:ext cx="3124200" cy="0"/>
           </a:xfrm>
           <a:prstGeom prst="line">
             <a:avLst/>
@@ -34629,14 +34835,14 @@
       </p:cxnSp>
       <p:sp>
         <p:nvSpPr>
-          <p:cNvPr id="13" name="TextBox 12"/>
+          <p:cNvPr id="17" name="TextBox 16"/>
           <p:cNvSpPr txBox="1"/>
           <p:nvPr/>
         </p:nvSpPr>
         <p:spPr>
           <a:xfrm>
-            <a:off x="3505200" y="2133600"/>
-            <a:ext cx="2305050" cy="1314450"/>
+            <a:off x="8305800" y="2247900"/>
+            <a:ext cx="3200400" cy="1524000"/>
           </a:xfrm>
           <a:prstGeom prst="rect">
             <a:avLst/>
@@ -34651,54 +34857,67 @@
           <a:p>
             <a:pPr algn="ctr"/>
             <a:r>
-              <a:rPr sz="1300" b="0">
+              <a:rPr sz="1400" b="0">
                 <a:solidFill>
                   <a:srgbClr val="222222"/>
                 </a:solidFill>
                 <a:latin typeface="Arial"/>
                 <a:ea typeface="AppleGothic"/>
               </a:rPr>
-              <a:t>동결된 저복잡도 tail 주변에서</a:t>
+              <a:t>unit bootstrap · paired 검정</a:t>
             </a:r>
           </a:p>
           <a:p>
             <a:pPr algn="ctr"/>
             <a:r>
-              <a:rPr sz="1300" b="0">
+              <a:rPr sz="1400" b="0">
                 <a:solidFill>
                   <a:srgbClr val="222222"/>
                 </a:solidFill>
                 <a:latin typeface="Arial"/>
                 <a:ea typeface="AppleGothic"/>
               </a:rPr>
-              <a:t>source가 지지하는 nonlinear</a:t>
+              <a:t>cross-domain stability</a:t>
             </a:r>
           </a:p>
           <a:p>
             <a:pPr algn="ctr"/>
             <a:r>
-              <a:rPr sz="1300" b="0">
+              <a:rPr sz="1400" b="0">
                 <a:solidFill>
                   <a:srgbClr val="222222"/>
                 </a:solidFill>
                 <a:latin typeface="Arial"/>
                 <a:ea typeface="AppleGothic"/>
               </a:rPr>
-              <a:t>residual만 제한적으로 학습</a:t>
-            </a:r>
-          </a:p>
-        </p:txBody>
-      </p:sp>
-      <p:sp>
-        <p:nvSpPr>
-          <p:cNvPr id="14" name="Rounded Rectangle 13"/>
+              <a:t>Selective Regression 동일 coverage</a:t>
+            </a:r>
+          </a:p>
+          <a:p>
+            <a:pPr algn="ctr"/>
+            <a:r>
+              <a:rPr sz="1400" b="0">
+                <a:solidFill>
+                  <a:srgbClr val="222222"/>
+                </a:solidFill>
+                <a:latin typeface="Arial"/>
+                <a:ea typeface="AppleGothic"/>
+              </a:rPr>
+              <a:t>prospective DS03까지 함께 검증</a:t>
+            </a:r>
+          </a:p>
+        </p:txBody>
+      </p:sp>
+      <p:sp>
+        <p:nvSpPr>
+          <p:cNvPr id="18" name="Rounded Rectangle 17"/>
           <p:cNvSpPr/>
           <p:nvPr/>
         </p:nvSpPr>
         <p:spPr>
           <a:xfrm>
-            <a:off x="6210300" y="1123950"/>
-            <a:ext cx="2647950" cy="2990850"/>
+            <a:off x="457200" y="4362450"/>
+            <a:ext cx="11277600" cy="1143000"/>
           </a:xfrm>
           <a:prstGeom prst="roundRect">
             <a:avLst>
@@ -34706,12 +34925,10 @@
             </a:avLst>
           </a:prstGeom>
           <a:solidFill>
-            <a:srgbClr val="FDF4E3"/>
+            <a:srgbClr val="222222"/>
           </a:solidFill>
-          <a:ln w="15875">
-            <a:solidFill>
-              <a:srgbClr val="E69F00"/>
-            </a:solidFill>
+          <a:ln>
+            <a:noFill/>
           </a:ln>
         </p:spPr>
         <p:style>
@@ -34738,14 +34955,14 @@
       </p:sp>
       <p:sp>
         <p:nvSpPr>
-          <p:cNvPr id="15" name="TextBox 14"/>
+          <p:cNvPr id="19" name="TextBox 18"/>
           <p:cNvSpPr txBox="1"/>
           <p:nvPr/>
         </p:nvSpPr>
         <p:spPr>
           <a:xfrm>
-            <a:off x="6381750" y="1352550"/>
-            <a:ext cx="2305050" cy="285750"/>
+            <a:off x="666750" y="4495800"/>
+            <a:ext cx="10858500" cy="323850"/>
           </a:xfrm>
           <a:prstGeom prst="rect">
             <a:avLst/>
@@ -34760,33 +34977,105 @@
           <a:p>
             <a:pPr algn="ctr"/>
             <a:r>
-              <a:rPr sz="1500" b="1">
-                <a:solidFill>
-                  <a:srgbClr val="E69F00"/>
-                </a:solidFill>
-                <a:latin typeface="Arial"/>
-                <a:ea typeface="AppleGothic"/>
-              </a:rPr>
-              <a:t>C3  Unit-evidence approval</a:t>
+              <a:rPr sz="1300" b="1">
+                <a:solidFill>
+                  <a:srgbClr val="FFFFFF"/>
+                </a:solidFill>
+                <a:latin typeface="Arial"/>
+                <a:ea typeface="AppleGothic"/>
+              </a:rPr>
+              <a:t>포지션  PP-X is a contract-conditioned, validation-approved prior-residual execution architecture, not a universal neural predictor.</a:t>
+            </a:r>
+          </a:p>
+        </p:txBody>
+      </p:sp>
+      <p:sp>
+        <p:nvSpPr>
+          <p:cNvPr id="20" name="TextBox 19"/>
+          <p:cNvSpPr txBox="1"/>
+          <p:nvPr/>
+        </p:nvSpPr>
+        <p:spPr>
+          <a:xfrm>
+            <a:off x="666750" y="4933950"/>
+            <a:ext cx="10858500" cy="400050"/>
+          </a:xfrm>
+          <a:prstGeom prst="rect">
+            <a:avLst/>
+          </a:prstGeom>
+          <a:noFill/>
+        </p:spPr>
+        <p:txBody>
+          <a:bodyPr wrap="square">
+            <a:spAutoFit/>
+          </a:bodyPr>
+          <a:lstStyle/>
+          <a:p>
+            <a:pPr algn="ctr"/>
+            <a:r>
+              <a:rPr sz="1300" b="0">
+                <a:solidFill>
+                  <a:srgbClr val="FFFFFF"/>
+                </a:solidFill>
+                <a:latin typeface="Arial"/>
+                <a:ea typeface="AppleGothic"/>
+              </a:rPr>
+              <a:t>주장 범위  평균 SOTA가 아니라, 동일 coverage에서 더 안전한 예측 조건 · 근거 없는 prior 거절 · unrestricted residual·generic selective regression보다 안전한 조건부 실행.</a:t>
+            </a:r>
+          </a:p>
+        </p:txBody>
+      </p:sp>
+      <p:sp>
+        <p:nvSpPr>
+          <p:cNvPr id="21" name="TextBox 20"/>
+          <p:cNvSpPr txBox="1"/>
+          <p:nvPr/>
+        </p:nvSpPr>
+        <p:spPr>
+          <a:xfrm>
+            <a:off x="457200" y="5734050"/>
+            <a:ext cx="11277600" cy="285750"/>
+          </a:xfrm>
+          <a:prstGeom prst="rect">
+            <a:avLst/>
+          </a:prstGeom>
+          <a:noFill/>
+        </p:spPr>
+        <p:txBody>
+          <a:bodyPr wrap="square">
+            <a:spAutoFit/>
+          </a:bodyPr>
+          <a:lstStyle/>
+          <a:p>
+            <a:pPr algn="ctr"/>
+            <a:r>
+              <a:rPr sz="1100" b="0">
+                <a:solidFill>
+                  <a:srgbClr val="666666"/>
+                </a:solidFill>
+                <a:latin typeface="Arial"/>
+                <a:ea typeface="AppleGothic"/>
+              </a:rPr>
+              <a:t>실증  equal-budget 8/9 · domain MAD Engression p=.0391 · Selective equal-coverage 5/5 · DS03 prior 거절 PASS / 정확도 우월 FAIL</a:t>
             </a:r>
           </a:p>
         </p:txBody>
       </p:sp>
       <p:cxnSp>
         <p:nvCxnSpPr>
-          <p:cNvPr id="16" name="Connector 15"/>
+          <p:cNvPr id="22" name="Connector 21"/>
           <p:cNvCxnSpPr/>
           <p:nvPr/>
         </p:nvCxnSpPr>
         <p:spPr>
           <a:xfrm>
-            <a:off x="6438900" y="1828800"/>
-            <a:ext cx="2190750" cy="0"/>
+            <a:off x="457200" y="6477000"/>
+            <a:ext cx="11277600" cy="0"/>
           </a:xfrm>
           <a:prstGeom prst="line">
             <a:avLst/>
           </a:prstGeom>
-          <a:ln w="15875">
+          <a:ln w="9525">
             <a:solidFill>
               <a:srgbClr val="E8E8E8"/>
             </a:solidFill>
@@ -34809,14 +35098,14 @@
       </p:cxnSp>
       <p:sp>
         <p:nvSpPr>
-          <p:cNvPr id="17" name="TextBox 16"/>
+          <p:cNvPr id="23" name="TextBox 22"/>
           <p:cNvSpPr txBox="1"/>
           <p:nvPr/>
         </p:nvSpPr>
         <p:spPr>
           <a:xfrm>
-            <a:off x="6381750" y="2133600"/>
-            <a:ext cx="2305050" cy="1314450"/>
+            <a:off x="457200" y="6534150"/>
+            <a:ext cx="7620000" cy="133350"/>
           </a:xfrm>
           <a:prstGeom prst="rect">
             <a:avLst/>
@@ -34829,303 +35118,16 @@
           </a:bodyPr>
           <a:lstStyle/>
           <a:p>
-            <a:pPr algn="ctr"/>
-            <a:r>
-              <a:rPr sz="1300" b="0">
-                <a:solidFill>
-                  <a:srgbClr val="222222"/>
-                </a:solidFill>
-                <a:latin typeface="Arial"/>
-                <a:ea typeface="AppleGothic"/>
-              </a:rPr>
-              <a:t>group-disjoint validation의</a:t>
-            </a:r>
-          </a:p>
-          <a:p>
-            <a:pPr algn="ctr"/>
-            <a:r>
-              <a:rPr sz="1300" b="0">
-                <a:solidFill>
-                  <a:srgbClr val="222222"/>
-                </a:solidFill>
-                <a:latin typeface="Arial"/>
-                <a:ea typeface="AppleGothic"/>
-              </a:rPr>
-              <a:t>이득 · unit wins · worst risk로</a:t>
-            </a:r>
-          </a:p>
-          <a:p>
-            <a:pPr algn="ctr"/>
-            <a:r>
-              <a:rPr sz="1300" b="0">
-                <a:solidFill>
-                  <a:srgbClr val="222222"/>
-                </a:solidFill>
-                <a:latin typeface="Arial"/>
-                <a:ea typeface="AppleGothic"/>
-              </a:rPr>
-              <a:t>executor 승인 또는 거절</a:t>
-            </a:r>
-          </a:p>
-        </p:txBody>
-      </p:sp>
-      <p:sp>
-        <p:nvSpPr>
-          <p:cNvPr id="18" name="Rounded Rectangle 17"/>
-          <p:cNvSpPr/>
-          <p:nvPr/>
-        </p:nvSpPr>
-        <p:spPr>
-          <a:xfrm>
-            <a:off x="9086850" y="1123950"/>
-            <a:ext cx="2647950" cy="2990850"/>
-          </a:xfrm>
-          <a:prstGeom prst="roundRect">
-            <a:avLst>
-              <a:gd name="adj" fmla="val 12000"/>
-            </a:avLst>
-          </a:prstGeom>
-          <a:solidFill>
-            <a:srgbClr val="F5F5F5"/>
-          </a:solidFill>
-          <a:ln w="15875">
-            <a:solidFill>
-              <a:srgbClr val="222222"/>
-            </a:solidFill>
-          </a:ln>
-        </p:spPr>
-        <p:style>
-          <a:lnRef idx="1">
-            <a:schemeClr val="accent1"/>
-          </a:lnRef>
-          <a:fillRef idx="3">
-            <a:schemeClr val="accent1"/>
-          </a:fillRef>
-          <a:effectRef idx="2">
-            <a:schemeClr val="accent1"/>
-          </a:effectRef>
-          <a:fontRef idx="minor">
-            <a:schemeClr val="lt1"/>
-          </a:fontRef>
-        </p:style>
-        <p:txBody>
-          <a:bodyPr rtlCol="0" anchor="ctr"/>
-          <a:lstStyle/>
-          <a:p>
-            <a:pPr algn="ctr"/>
-          </a:p>
-        </p:txBody>
-      </p:sp>
-      <p:sp>
-        <p:nvSpPr>
-          <p:cNvPr id="19" name="TextBox 18"/>
-          <p:cNvSpPr txBox="1"/>
-          <p:nvPr/>
-        </p:nvSpPr>
-        <p:spPr>
-          <a:xfrm>
-            <a:off x="9258300" y="1352550"/>
-            <a:ext cx="2305050" cy="285750"/>
-          </a:xfrm>
-          <a:prstGeom prst="rect">
-            <a:avLst/>
-          </a:prstGeom>
-          <a:noFill/>
-        </p:spPr>
-        <p:txBody>
-          <a:bodyPr wrap="square">
-            <a:spAutoFit/>
-          </a:bodyPr>
-          <a:lstStyle/>
-          <a:p>
-            <a:pPr algn="ctr"/>
-            <a:r>
-              <a:rPr sz="1500" b="1">
-                <a:solidFill>
-                  <a:srgbClr val="222222"/>
-                </a:solidFill>
-                <a:latin typeface="Arial"/>
-                <a:ea typeface="AppleGothic"/>
-              </a:rPr>
-              <a:t>C4  Frozen execution</a:t>
-            </a:r>
-          </a:p>
-        </p:txBody>
-      </p:sp>
-      <p:cxnSp>
-        <p:nvCxnSpPr>
-          <p:cNvPr id="20" name="Connector 19"/>
-          <p:cNvCxnSpPr/>
-          <p:nvPr/>
-        </p:nvCxnSpPr>
-        <p:spPr>
-          <a:xfrm>
-            <a:off x="9315450" y="1828800"/>
-            <a:ext cx="2190750" cy="0"/>
-          </a:xfrm>
-          <a:prstGeom prst="line">
-            <a:avLst/>
-          </a:prstGeom>
-          <a:ln w="15875">
-            <a:solidFill>
-              <a:srgbClr val="E8E8E8"/>
-            </a:solidFill>
-          </a:ln>
-        </p:spPr>
-        <p:style>
-          <a:lnRef idx="2">
-            <a:schemeClr val="accent1"/>
-          </a:lnRef>
-          <a:fillRef idx="0">
-            <a:schemeClr val="accent1"/>
-          </a:fillRef>
-          <a:effectRef idx="1">
-            <a:schemeClr val="accent1"/>
-          </a:effectRef>
-          <a:fontRef idx="minor">
-            <a:schemeClr val="tx1"/>
-          </a:fontRef>
-        </p:style>
-      </p:cxnSp>
-      <p:sp>
-        <p:nvSpPr>
-          <p:cNvPr id="21" name="TextBox 20"/>
-          <p:cNvSpPr txBox="1"/>
-          <p:nvPr/>
-        </p:nvSpPr>
-        <p:spPr>
-          <a:xfrm>
-            <a:off x="9258300" y="2133600"/>
-            <a:ext cx="2305050" cy="1314450"/>
-          </a:xfrm>
-          <a:prstGeom prst="rect">
-            <a:avLst/>
-          </a:prstGeom>
-          <a:noFill/>
-        </p:spPr>
-        <p:txBody>
-          <a:bodyPr wrap="square">
-            <a:spAutoFit/>
-          </a:bodyPr>
-          <a:lstStyle/>
-          <a:p>
-            <a:pPr algn="ctr"/>
-            <a:r>
-              <a:rPr sz="1300" b="0">
-                <a:solidFill>
-                  <a:srgbClr val="222222"/>
-                </a:solidFill>
-                <a:latin typeface="Arial"/>
-                <a:ea typeface="AppleGothic"/>
-              </a:rPr>
-              <a:t>승인 route 하나를 test 전에 고정</a:t>
-            </a:r>
-          </a:p>
-          <a:p>
-            <a:pPr algn="ctr"/>
-            <a:r>
-              <a:rPr sz="1300" b="0">
-                <a:solidFill>
-                  <a:srgbClr val="222222"/>
-                </a:solidFill>
-                <a:latin typeface="Arial"/>
-                <a:ea typeface="AppleGothic"/>
-              </a:rPr>
-              <a:t>근거가 없으면 exact fallback</a:t>
-            </a:r>
-          </a:p>
-          <a:p>
-            <a:pPr algn="ctr"/>
-            <a:r>
-              <a:rPr sz="1300" b="0">
-                <a:solidFill>
-                  <a:srgbClr val="222222"/>
-                </a:solidFill>
-                <a:latin typeface="Arial"/>
-                <a:ea typeface="AppleGothic"/>
-              </a:rPr>
-              <a:t>성공·실패 결과를 함께 보고</a:t>
-            </a:r>
-          </a:p>
-        </p:txBody>
-      </p:sp>
-      <p:sp>
-        <p:nvSpPr>
-          <p:cNvPr id="22" name="Rounded Rectangle 21"/>
-          <p:cNvSpPr/>
-          <p:nvPr/>
-        </p:nvSpPr>
-        <p:spPr>
-          <a:xfrm>
-            <a:off x="457200" y="4362450"/>
-            <a:ext cx="11277600" cy="1143000"/>
-          </a:xfrm>
-          <a:prstGeom prst="roundRect">
-            <a:avLst>
-              <a:gd name="adj" fmla="val 12000"/>
-            </a:avLst>
-          </a:prstGeom>
-          <a:solidFill>
-            <a:srgbClr val="222222"/>
-          </a:solidFill>
-          <a:ln>
-            <a:noFill/>
-          </a:ln>
-        </p:spPr>
-        <p:style>
-          <a:lnRef idx="1">
-            <a:schemeClr val="accent1"/>
-          </a:lnRef>
-          <a:fillRef idx="3">
-            <a:schemeClr val="accent1"/>
-          </a:fillRef>
-          <a:effectRef idx="2">
-            <a:schemeClr val="accent1"/>
-          </a:effectRef>
-          <a:fontRef idx="minor">
-            <a:schemeClr val="lt1"/>
-          </a:fontRef>
-        </p:style>
-        <p:txBody>
-          <a:bodyPr rtlCol="0" anchor="ctr"/>
-          <a:lstStyle/>
-          <a:p>
-            <a:pPr algn="ctr"/>
-          </a:p>
-        </p:txBody>
-      </p:sp>
-      <p:sp>
-        <p:nvSpPr>
-          <p:cNvPr id="23" name="TextBox 22"/>
-          <p:cNvSpPr txBox="1"/>
-          <p:nvPr/>
-        </p:nvSpPr>
-        <p:spPr>
-          <a:xfrm>
-            <a:off x="666750" y="4495800"/>
-            <a:ext cx="10858500" cy="323850"/>
-          </a:xfrm>
-          <a:prstGeom prst="rect">
-            <a:avLst/>
-          </a:prstGeom>
-          <a:noFill/>
-        </p:spPr>
-        <p:txBody>
-          <a:bodyPr wrap="square">
-            <a:spAutoFit/>
-          </a:bodyPr>
-          <a:lstStyle/>
-          <a:p>
-            <a:pPr algn="ctr"/>
-            <a:r>
-              <a:rPr sz="1300" b="1">
-                <a:solidFill>
-                  <a:srgbClr val="FFFFFF"/>
-                </a:solidFill>
-                <a:latin typeface="Arial"/>
-                <a:ea typeface="AppleGothic"/>
-              </a:rPr>
-              <a:t>결합 방식  Contract C → 허용 후보 E(C) 제한 → prior-residual 후보 학습 → unit-risk 제약 아래 validation-best executor 선택 → frozen route / fallback</a:t>
+            <a:pPr algn="l"/>
+            <a:r>
+              <a:rPr sz="900" b="0">
+                <a:solidFill>
+                  <a:srgbClr val="666666"/>
+                </a:solidFill>
+                <a:latin typeface="Arial"/>
+                <a:ea typeface="AppleGothic"/>
+              </a:rPr>
+              <a:t>SPS Lab  ·  Prior-Adaptive Extrapolation  ·  PP-X</a:t>
             </a:r>
           </a:p>
         </p:txBody>
@@ -35133,149 +35135,6 @@
       <p:sp>
         <p:nvSpPr>
           <p:cNvPr id="24" name="TextBox 23"/>
-          <p:cNvSpPr txBox="1"/>
-          <p:nvPr/>
-        </p:nvSpPr>
-        <p:spPr>
-          <a:xfrm>
-            <a:off x="666750" y="4933950"/>
-            <a:ext cx="10858500" cy="400050"/>
-          </a:xfrm>
-          <a:prstGeom prst="rect">
-            <a:avLst/>
-          </a:prstGeom>
-          <a:noFill/>
-        </p:spPr>
-        <p:txBody>
-          <a:bodyPr wrap="square">
-            <a:spAutoFit/>
-          </a:bodyPr>
-          <a:lstStyle/>
-          <a:p>
-            <a:pPr algn="ctr"/>
-            <a:r>
-              <a:rPr sz="1300" b="0">
-                <a:solidFill>
-                  <a:srgbClr val="FFFFFF"/>
-                </a:solidFill>
-                <a:latin typeface="Arial"/>
-                <a:ea typeface="AppleGothic"/>
-              </a:rPr>
-              <a:t>차별점  prior+residual·validation·abstention을 나열한 것이 아니라, 앞 단계의 출력이 다음 단계의 허용 입력을 제한하는 하나의 실행 알고리즘으로 만든다.</a:t>
-            </a:r>
-          </a:p>
-        </p:txBody>
-      </p:sp>
-      <p:sp>
-        <p:nvSpPr>
-          <p:cNvPr id="25" name="TextBox 24"/>
-          <p:cNvSpPr txBox="1"/>
-          <p:nvPr/>
-        </p:nvSpPr>
-        <p:spPr>
-          <a:xfrm>
-            <a:off x="457200" y="5734050"/>
-            <a:ext cx="11277600" cy="285750"/>
-          </a:xfrm>
-          <a:prstGeom prst="rect">
-            <a:avLst/>
-          </a:prstGeom>
-          <a:noFill/>
-        </p:spPr>
-        <p:txBody>
-          <a:bodyPr wrap="square">
-            <a:spAutoFit/>
-          </a:bodyPr>
-          <a:lstStyle/>
-          <a:p>
-            <a:pPr algn="ctr"/>
-            <a:r>
-              <a:rPr sz="1100" b="0">
-                <a:solidFill>
-                  <a:srgbClr val="666666"/>
-                </a:solidFill>
-                <a:latin typeface="Arial"/>
-                <a:ea typeface="AppleGothic"/>
-              </a:rPr>
-              <a:t>실증  9개 retrospective setting 중 동일예산 최강 비교모델 대비 8개 우세 · DS03에서는 prior 거절 성공, Engression보다 정확도 우월은 미확증</a:t>
-            </a:r>
-          </a:p>
-        </p:txBody>
-      </p:sp>
-      <p:cxnSp>
-        <p:nvCxnSpPr>
-          <p:cNvPr id="26" name="Connector 25"/>
-          <p:cNvCxnSpPr/>
-          <p:nvPr/>
-        </p:nvCxnSpPr>
-        <p:spPr>
-          <a:xfrm>
-            <a:off x="457200" y="6477000"/>
-            <a:ext cx="11277600" cy="0"/>
-          </a:xfrm>
-          <a:prstGeom prst="line">
-            <a:avLst/>
-          </a:prstGeom>
-          <a:ln w="9525">
-            <a:solidFill>
-              <a:srgbClr val="E8E8E8"/>
-            </a:solidFill>
-          </a:ln>
-        </p:spPr>
-        <p:style>
-          <a:lnRef idx="2">
-            <a:schemeClr val="accent1"/>
-          </a:lnRef>
-          <a:fillRef idx="0">
-            <a:schemeClr val="accent1"/>
-          </a:fillRef>
-          <a:effectRef idx="1">
-            <a:schemeClr val="accent1"/>
-          </a:effectRef>
-          <a:fontRef idx="minor">
-            <a:schemeClr val="tx1"/>
-          </a:fontRef>
-        </p:style>
-      </p:cxnSp>
-      <p:sp>
-        <p:nvSpPr>
-          <p:cNvPr id="27" name="TextBox 26"/>
-          <p:cNvSpPr txBox="1"/>
-          <p:nvPr/>
-        </p:nvSpPr>
-        <p:spPr>
-          <a:xfrm>
-            <a:off x="457200" y="6534150"/>
-            <a:ext cx="7620000" cy="133350"/>
-          </a:xfrm>
-          <a:prstGeom prst="rect">
-            <a:avLst/>
-          </a:prstGeom>
-          <a:noFill/>
-        </p:spPr>
-        <p:txBody>
-          <a:bodyPr wrap="square">
-            <a:spAutoFit/>
-          </a:bodyPr>
-          <a:lstStyle/>
-          <a:p>
-            <a:pPr algn="l"/>
-            <a:r>
-              <a:rPr sz="900" b="0">
-                <a:solidFill>
-                  <a:srgbClr val="666666"/>
-                </a:solidFill>
-                <a:latin typeface="Arial"/>
-                <a:ea typeface="AppleGothic"/>
-              </a:rPr>
-              <a:t>SPS Lab  ·  Prior-Adaptive Extrapolation  ·  PP-X</a:t>
-            </a:r>
-          </a:p>
-        </p:txBody>
-      </p:sp>
-      <p:sp>
-        <p:nvSpPr>
-          <p:cNvPr id="28" name="TextBox 27"/>
           <p:cNvSpPr txBox="1"/>
           <p:nvPr/>
         </p:nvSpPr>

</xml_diff>